<commit_message>
Modificata la presentazione, aggiunte più informazioni riguardo i risonatori
</commit_message>
<xml_diff>
--- a/presentazione_sunto_libro_di_Righi/presentazione_veloce_testo_Righi.pptx
+++ b/presentazione_sunto_libro_di_Righi/presentazione_veloce_testo_Righi.pptx
@@ -5,30 +5,31 @@
     <p:sldMasterId id="2147483648" r:id="rId1"/>
   </p:sldMasterIdLst>
   <p:notesMasterIdLst>
-    <p:notesMasterId r:id="rId23"/>
+    <p:notesMasterId r:id="rId24"/>
   </p:notesMasterIdLst>
   <p:sldIdLst>
     <p:sldId id="256" r:id="rId2"/>
     <p:sldId id="262" r:id="rId3"/>
     <p:sldId id="269" r:id="rId4"/>
     <p:sldId id="267" r:id="rId5"/>
-    <p:sldId id="258" r:id="rId6"/>
-    <p:sldId id="259" r:id="rId7"/>
-    <p:sldId id="268" r:id="rId8"/>
-    <p:sldId id="260" r:id="rId9"/>
-    <p:sldId id="261" r:id="rId10"/>
-    <p:sldId id="270" r:id="rId11"/>
-    <p:sldId id="271" r:id="rId12"/>
-    <p:sldId id="272" r:id="rId13"/>
-    <p:sldId id="273" r:id="rId14"/>
-    <p:sldId id="274" r:id="rId15"/>
-    <p:sldId id="275" r:id="rId16"/>
-    <p:sldId id="264" r:id="rId17"/>
-    <p:sldId id="276" r:id="rId18"/>
-    <p:sldId id="277" r:id="rId19"/>
-    <p:sldId id="278" r:id="rId20"/>
-    <p:sldId id="279" r:id="rId21"/>
-    <p:sldId id="280" r:id="rId22"/>
+    <p:sldId id="281" r:id="rId6"/>
+    <p:sldId id="258" r:id="rId7"/>
+    <p:sldId id="259" r:id="rId8"/>
+    <p:sldId id="268" r:id="rId9"/>
+    <p:sldId id="260" r:id="rId10"/>
+    <p:sldId id="261" r:id="rId11"/>
+    <p:sldId id="270" r:id="rId12"/>
+    <p:sldId id="271" r:id="rId13"/>
+    <p:sldId id="272" r:id="rId14"/>
+    <p:sldId id="273" r:id="rId15"/>
+    <p:sldId id="274" r:id="rId16"/>
+    <p:sldId id="275" r:id="rId17"/>
+    <p:sldId id="264" r:id="rId18"/>
+    <p:sldId id="276" r:id="rId19"/>
+    <p:sldId id="277" r:id="rId20"/>
+    <p:sldId id="278" r:id="rId21"/>
+    <p:sldId id="279" r:id="rId22"/>
+    <p:sldId id="280" r:id="rId23"/>
   </p:sldIdLst>
   <p:sldSz cx="12192000" cy="6858000"/>
   <p:notesSz cx="6858000" cy="9144000"/>
@@ -217,7 +218,7 @@
           <a:p>
             <a:fld id="{5F163503-BC98-4576-AAA0-4ED2B62CB37F}" type="datetimeFigureOut">
               <a:rPr lang="it-IT" smtClean="0"/>
-              <a:t>09/10/2026</a:t>
+              <a:t>11/10/2026</a:t>
             </a:fld>
             <a:endParaRPr lang="it-IT"/>
           </a:p>
@@ -646,7 +647,7 @@
             </a:r>
             <a:r>
               <a:rPr lang="it-IT" dirty="0"/>
-              <a:t> 185 del .pdf</a:t>
+              <a:t> 170 del .pdf</a:t>
             </a:r>
           </a:p>
         </p:txBody>
@@ -677,7 +678,7 @@
     </p:spTree>
     <p:extLst>
       <p:ext uri="{BB962C8B-B14F-4D97-AF65-F5344CB8AC3E}">
-        <p14:creationId xmlns:p14="http://schemas.microsoft.com/office/powerpoint/2010/main" val="1258015411"/>
+        <p14:creationId xmlns:p14="http://schemas.microsoft.com/office/powerpoint/2010/main" val="152549240"/>
       </p:ext>
     </p:extLst>
   </p:cSld>
@@ -732,8 +733,12 @@
           <a:lstStyle/>
           <a:p>
             <a:r>
-              <a:rPr lang="it-IT" dirty="0"/>
-              <a:t>Pag. 214 del .pdf</a:t>
+              <a:rPr lang="it-IT" dirty="0" err="1"/>
+              <a:t>Pag</a:t>
+            </a:r>
+            <a:r>
+              <a:rPr lang="it-IT" dirty="0"/>
+              <a:t> 185 del .pdf</a:t>
             </a:r>
           </a:p>
         </p:txBody>
@@ -764,7 +769,7 @@
     </p:spTree>
     <p:extLst>
       <p:ext uri="{BB962C8B-B14F-4D97-AF65-F5344CB8AC3E}">
-        <p14:creationId xmlns:p14="http://schemas.microsoft.com/office/powerpoint/2010/main" val="894022671"/>
+        <p14:creationId xmlns:p14="http://schemas.microsoft.com/office/powerpoint/2010/main" val="1258015411"/>
       </p:ext>
     </p:extLst>
   </p:cSld>
@@ -820,8 +825,27 @@
           <a:p>
             <a:r>
               <a:rPr lang="it-IT" dirty="0"/>
-              <a:t>pag. 234 del .pdf</a:t>
-            </a:r>
+              <a:t>Pag. 214 del .pdf</a:t>
+            </a:r>
+            <a:br>
+              <a:rPr lang="it-IT" dirty="0"/>
+            </a:br>
+            <a:br>
+              <a:rPr lang="it-IT" dirty="0"/>
+            </a:br>
+            <a:r>
+              <a:rPr lang="it-IT" sz="1200" kern="1200" dirty="0">
+                <a:solidFill>
+                  <a:schemeClr val="tx1"/>
+                </a:solidFill>
+                <a:effectLst/>
+                <a:latin typeface="+mn-lt"/>
+                <a:ea typeface="+mn-ea"/>
+                <a:cs typeface="+mn-cs"/>
+              </a:rPr>
+              <a:t>Si collega al Capitolo I della Parte Prima (§ 1 e § 3). Nella sezione dedicata alle forme alternative degli oscillatori (§ 3), Righi discute la possibilità teorica di generare onde tramite dispositivi meccanici e rimanda a questa nota per lo sviluppo matematico</a:t>
+            </a:r>
+            <a:endParaRPr lang="it-IT" dirty="0"/>
           </a:p>
         </p:txBody>
       </p:sp>
@@ -851,7 +875,7 @@
     </p:spTree>
     <p:extLst>
       <p:ext uri="{BB962C8B-B14F-4D97-AF65-F5344CB8AC3E}">
-        <p14:creationId xmlns:p14="http://schemas.microsoft.com/office/powerpoint/2010/main" val="3254824969"/>
+        <p14:creationId xmlns:p14="http://schemas.microsoft.com/office/powerpoint/2010/main" val="894022671"/>
       </p:ext>
     </p:extLst>
   </p:cSld>
@@ -907,8 +931,74 @@
           <a:p>
             <a:r>
               <a:rPr lang="it-IT" dirty="0"/>
-              <a:t>Pag. 237 del .pdf</a:t>
-            </a:r>
+              <a:t>pag. 234 del .pdf</a:t>
+            </a:r>
+            <a:br>
+              <a:rPr lang="it-IT" dirty="0"/>
+            </a:br>
+            <a:br>
+              <a:rPr lang="it-IT" dirty="0"/>
+            </a:br>
+            <a:r>
+              <a:rPr lang="it-IT" sz="1200" kern="1200" dirty="0">
+                <a:solidFill>
+                  <a:schemeClr val="tx1"/>
+                </a:solidFill>
+                <a:effectLst/>
+                <a:latin typeface="+mn-lt"/>
+                <a:ea typeface="+mn-ea"/>
+                <a:cs typeface="+mn-cs"/>
+              </a:rPr>
+              <a:t>Si collega al </a:t>
+            </a:r>
+            <a:r>
+              <a:rPr lang="it-IT" sz="1200" b="0" kern="1200" dirty="0">
+                <a:solidFill>
+                  <a:schemeClr val="tx1"/>
+                </a:solidFill>
+                <a:effectLst/>
+                <a:latin typeface="+mn-lt"/>
+                <a:ea typeface="+mn-ea"/>
+                <a:cs typeface="+mn-cs"/>
+              </a:rPr>
+              <a:t>Capitolo II della Parte Prima (§ 18, "Onde secondarie di una sfera dielettrica" ) </a:t>
+            </a:r>
+            <a:r>
+              <a:rPr lang="it-IT" sz="1200" kern="1200" dirty="0">
+                <a:solidFill>
+                  <a:schemeClr val="tx1"/>
+                </a:solidFill>
+                <a:effectLst/>
+                <a:latin typeface="+mn-lt"/>
+                <a:ea typeface="+mn-ea"/>
+                <a:cs typeface="+mn-cs"/>
+              </a:rPr>
+              <a:t>e al Capitolo III della Parte Seconda (§ 34-35). </a:t>
+            </a:r>
+            <a:br>
+              <a:rPr lang="it-IT" sz="1200" kern="1200" dirty="0">
+                <a:solidFill>
+                  <a:schemeClr val="tx1"/>
+                </a:solidFill>
+                <a:effectLst/>
+                <a:latin typeface="+mn-lt"/>
+                <a:ea typeface="+mn-ea"/>
+                <a:cs typeface="+mn-cs"/>
+              </a:rPr>
+            </a:br>
+            <a:r>
+              <a:rPr lang="it-IT" sz="1200" kern="1200" dirty="0">
+                <a:solidFill>
+                  <a:schemeClr val="tx1"/>
+                </a:solidFill>
+                <a:effectLst/>
+                <a:latin typeface="+mn-lt"/>
+                <a:ea typeface="+mn-ea"/>
+                <a:cs typeface="+mn-cs"/>
+              </a:rPr>
+              <a:t>Fornisce il modello teorico per spiegare l'emissione di onde secondarie da parte di corpi sferici di paraffina o altri isolanti colpiti dal fascio dell'oscillatore</a:t>
+            </a:r>
+            <a:endParaRPr lang="it-IT" dirty="0"/>
           </a:p>
         </p:txBody>
       </p:sp>
@@ -938,7 +1028,7 @@
     </p:spTree>
     <p:extLst>
       <p:ext uri="{BB962C8B-B14F-4D97-AF65-F5344CB8AC3E}">
-        <p14:creationId xmlns:p14="http://schemas.microsoft.com/office/powerpoint/2010/main" val="1765547128"/>
+        <p14:creationId xmlns:p14="http://schemas.microsoft.com/office/powerpoint/2010/main" val="3254824969"/>
       </p:ext>
     </p:extLst>
   </p:cSld>
@@ -994,8 +1084,85 @@
           <a:p>
             <a:r>
               <a:rPr lang="it-IT" dirty="0"/>
-              <a:t>Pag. 242 del .pdf</a:t>
-            </a:r>
+              <a:t>Pag. 237 del .pdf</a:t>
+            </a:r>
+          </a:p>
+          <a:p>
+            <a:endParaRPr lang="it-IT" dirty="0"/>
+          </a:p>
+          <a:p>
+            <a:r>
+              <a:rPr lang="it-IT" sz="1200" b="0" kern="1200" dirty="0">
+                <a:solidFill>
+                  <a:schemeClr val="tx1"/>
+                </a:solidFill>
+                <a:effectLst/>
+                <a:latin typeface="+mn-lt"/>
+                <a:ea typeface="+mn-ea"/>
+                <a:cs typeface="+mn-cs"/>
+              </a:rPr>
+              <a:t>Collegamento con i capitoli</a:t>
+            </a:r>
+            <a:r>
+              <a:rPr lang="it-IT" sz="1200" kern="1200" dirty="0">
+                <a:solidFill>
+                  <a:schemeClr val="tx1"/>
+                </a:solidFill>
+                <a:effectLst/>
+                <a:latin typeface="+mn-lt"/>
+                <a:ea typeface="+mn-ea"/>
+                <a:cs typeface="+mn-cs"/>
+              </a:rPr>
+              <a:t>: Si collega al </a:t>
+            </a:r>
+            <a:r>
+              <a:rPr lang="it-IT" sz="1200" b="0" kern="1200" dirty="0">
+                <a:solidFill>
+                  <a:schemeClr val="tx1"/>
+                </a:solidFill>
+                <a:effectLst/>
+                <a:latin typeface="+mn-lt"/>
+                <a:ea typeface="+mn-ea"/>
+                <a:cs typeface="+mn-cs"/>
+              </a:rPr>
+              <a:t>Capitolo II della Parte Prima (§ 19, "Onde secondarie di un cilindro dielettrico" ) </a:t>
+            </a:r>
+            <a:r>
+              <a:rPr lang="it-IT" sz="1200" kern="1200" dirty="0">
+                <a:solidFill>
+                  <a:schemeClr val="tx1"/>
+                </a:solidFill>
+                <a:effectLst/>
+                <a:latin typeface="+mn-lt"/>
+                <a:ea typeface="+mn-ea"/>
+                <a:cs typeface="+mn-cs"/>
+              </a:rPr>
+              <a:t>e al Capitolo III della Parte Seconda (§ 34-35). </a:t>
+            </a:r>
+            <a:br>
+              <a:rPr lang="it-IT" sz="1200" kern="1200" dirty="0">
+                <a:solidFill>
+                  <a:schemeClr val="tx1"/>
+                </a:solidFill>
+                <a:effectLst/>
+                <a:latin typeface="+mn-lt"/>
+                <a:ea typeface="+mn-ea"/>
+                <a:cs typeface="+mn-cs"/>
+              </a:rPr>
+            </a:br>
+            <a:r>
+              <a:rPr lang="it-IT" sz="1200" kern="1200" dirty="0">
+                <a:solidFill>
+                  <a:schemeClr val="tx1"/>
+                </a:solidFill>
+                <a:effectLst/>
+                <a:latin typeface="+mn-lt"/>
+                <a:ea typeface="+mn-ea"/>
+                <a:cs typeface="+mn-cs"/>
+              </a:rPr>
+              <a:t>Spiega matematicamente come la forma cilindrica dell'isolante alteri il campo incidente creando una polarizzazione locale sorgente di onde secondarie</a:t>
+            </a:r>
+            <a:endParaRPr lang="it-IT" dirty="0"/>
           </a:p>
         </p:txBody>
       </p:sp>
@@ -1025,7 +1192,7 @@
     </p:spTree>
     <p:extLst>
       <p:ext uri="{BB962C8B-B14F-4D97-AF65-F5344CB8AC3E}">
-        <p14:creationId xmlns:p14="http://schemas.microsoft.com/office/powerpoint/2010/main" val="3637323367"/>
+        <p14:creationId xmlns:p14="http://schemas.microsoft.com/office/powerpoint/2010/main" val="1765547128"/>
       </p:ext>
     </p:extLst>
   </p:cSld>
@@ -1081,8 +1248,109 @@
           <a:p>
             <a:r>
               <a:rPr lang="it-IT" dirty="0"/>
-              <a:t>Pag. 255 del .pdf</a:t>
-            </a:r>
+              <a:t>Pag. 242 del .pdf</a:t>
+            </a:r>
+          </a:p>
+          <a:p>
+            <a:endParaRPr lang="it-IT" dirty="0"/>
+          </a:p>
+          <a:p>
+            <a:r>
+              <a:rPr lang="it-IT" sz="1200" b="0" kern="1200" dirty="0">
+                <a:solidFill>
+                  <a:schemeClr val="tx1"/>
+                </a:solidFill>
+                <a:effectLst/>
+                <a:latin typeface="+mn-lt"/>
+                <a:ea typeface="+mn-ea"/>
+                <a:cs typeface="+mn-cs"/>
+              </a:rPr>
+              <a:t>Collegamento con i capitoli</a:t>
+            </a:r>
+            <a:r>
+              <a:rPr lang="it-IT" sz="1200" kern="1200" dirty="0">
+                <a:solidFill>
+                  <a:schemeClr val="tx1"/>
+                </a:solidFill>
+                <a:effectLst/>
+                <a:latin typeface="+mn-lt"/>
+                <a:ea typeface="+mn-ea"/>
+                <a:cs typeface="+mn-cs"/>
+              </a:rPr>
+              <a:t>: Si collega al </a:t>
+            </a:r>
+            <a:r>
+              <a:rPr lang="it-IT" sz="1200" b="0" kern="1200" dirty="0">
+                <a:solidFill>
+                  <a:schemeClr val="tx1"/>
+                </a:solidFill>
+                <a:effectLst/>
+                <a:latin typeface="+mn-lt"/>
+                <a:ea typeface="+mn-ea"/>
+                <a:cs typeface="+mn-cs"/>
+              </a:rPr>
+              <a:t>Capitolo V ( Riflessione , § 38-40)</a:t>
+            </a:r>
+            <a:r>
+              <a:rPr lang="it-IT" sz="1200" kern="1200" dirty="0">
+                <a:solidFill>
+                  <a:schemeClr val="tx1"/>
+                </a:solidFill>
+                <a:effectLst/>
+                <a:latin typeface="+mn-lt"/>
+                <a:ea typeface="+mn-ea"/>
+                <a:cs typeface="+mn-cs"/>
+              </a:rPr>
+              <a:t> e al </a:t>
+            </a:r>
+            <a:r>
+              <a:rPr lang="it-IT" sz="1200" b="0" kern="1200" dirty="0">
+                <a:solidFill>
+                  <a:schemeClr val="tx1"/>
+                </a:solidFill>
+                <a:effectLst/>
+                <a:latin typeface="+mn-lt"/>
+                <a:ea typeface="+mn-ea"/>
+                <a:cs typeface="+mn-cs"/>
+              </a:rPr>
+              <a:t>Capitolo VI ( Rifrazione , § 45-47) della Parte Seconda.</a:t>
+            </a:r>
+            <a:r>
+              <a:rPr lang="it-IT" sz="1200" kern="1200" dirty="0">
+                <a:solidFill>
+                  <a:schemeClr val="tx1"/>
+                </a:solidFill>
+                <a:effectLst/>
+                <a:latin typeface="+mn-lt"/>
+                <a:ea typeface="+mn-ea"/>
+                <a:cs typeface="+mn-cs"/>
+              </a:rPr>
+              <a:t> </a:t>
+            </a:r>
+            <a:br>
+              <a:rPr lang="it-IT" sz="1200" kern="1200" dirty="0">
+                <a:solidFill>
+                  <a:schemeClr val="tx1"/>
+                </a:solidFill>
+                <a:effectLst/>
+                <a:latin typeface="+mn-lt"/>
+                <a:ea typeface="+mn-ea"/>
+                <a:cs typeface="+mn-cs"/>
+              </a:rPr>
+            </a:br>
+            <a:r>
+              <a:rPr lang="it-IT" sz="1200" kern="1200" dirty="0">
+                <a:solidFill>
+                  <a:schemeClr val="tx1"/>
+                </a:solidFill>
+                <a:effectLst/>
+                <a:latin typeface="+mn-lt"/>
+                <a:ea typeface="+mn-ea"/>
+                <a:cs typeface="+mn-cs"/>
+              </a:rPr>
+              <a:t>Costituisce la giustificazione analitica degli esperimenti con specchi, prismi, lenti e la misurazione degli indici di rifrazione delle onde elettromagnetiche</a:t>
+            </a:r>
+            <a:endParaRPr lang="it-IT" dirty="0"/>
           </a:p>
         </p:txBody>
       </p:sp>
@@ -1112,7 +1380,7 @@
     </p:spTree>
     <p:extLst>
       <p:ext uri="{BB962C8B-B14F-4D97-AF65-F5344CB8AC3E}">
-        <p14:creationId xmlns:p14="http://schemas.microsoft.com/office/powerpoint/2010/main" val="2264837903"/>
+        <p14:creationId xmlns:p14="http://schemas.microsoft.com/office/powerpoint/2010/main" val="3637323367"/>
       </p:ext>
     </p:extLst>
   </p:cSld>
@@ -1168,8 +1436,85 @@
           <a:p>
             <a:r>
               <a:rPr lang="it-IT" dirty="0"/>
-              <a:t>Pag. 260 del .pdf</a:t>
-            </a:r>
+              <a:t>Pag. 255 del .pdf</a:t>
+            </a:r>
+          </a:p>
+          <a:p>
+            <a:endParaRPr lang="it-IT" dirty="0"/>
+          </a:p>
+          <a:p>
+            <a:r>
+              <a:rPr lang="it-IT" sz="1200" b="0" kern="1200" dirty="0">
+                <a:solidFill>
+                  <a:schemeClr val="tx1"/>
+                </a:solidFill>
+                <a:effectLst/>
+                <a:latin typeface="+mn-lt"/>
+                <a:ea typeface="+mn-ea"/>
+                <a:cs typeface="+mn-cs"/>
+              </a:rPr>
+              <a:t>Collegamento con i capitoli: Si collega al Capitolo V della Parte Seconda (§ 41, § 42 e § 43, "Riflessione </a:t>
+            </a:r>
+            <a:r>
+              <a:rPr lang="it-IT" sz="1200" b="0" kern="1200" dirty="0" err="1">
+                <a:solidFill>
+                  <a:schemeClr val="tx1"/>
+                </a:solidFill>
+                <a:effectLst/>
+                <a:latin typeface="+mn-lt"/>
+                <a:ea typeface="+mn-ea"/>
+                <a:cs typeface="+mn-cs"/>
+              </a:rPr>
+              <a:t>elittica</a:t>
+            </a:r>
+            <a:r>
+              <a:rPr lang="it-IT" sz="1200" b="0" kern="1200" dirty="0">
+                <a:solidFill>
+                  <a:schemeClr val="tx1"/>
+                </a:solidFill>
+                <a:effectLst/>
+                <a:latin typeface="+mn-lt"/>
+                <a:ea typeface="+mn-ea"/>
+                <a:cs typeface="+mn-cs"/>
+              </a:rPr>
+              <a:t>"</a:t>
+            </a:r>
+            <a:r>
+              <a:rPr lang="it-IT" sz="1200" kern="1200" dirty="0">
+                <a:solidFill>
+                  <a:schemeClr val="tx1"/>
+                </a:solidFill>
+                <a:effectLst/>
+                <a:latin typeface="+mn-lt"/>
+                <a:ea typeface="+mn-ea"/>
+                <a:cs typeface="+mn-cs"/>
+              </a:rPr>
+              <a:t> ). </a:t>
+            </a:r>
+            <a:br>
+              <a:rPr lang="it-IT" sz="1200" kern="1200" dirty="0">
+                <a:solidFill>
+                  <a:schemeClr val="tx1"/>
+                </a:solidFill>
+                <a:effectLst/>
+                <a:latin typeface="+mn-lt"/>
+                <a:ea typeface="+mn-ea"/>
+                <a:cs typeface="+mn-cs"/>
+              </a:rPr>
+            </a:br>
+            <a:r>
+              <a:rPr lang="it-IT" sz="1200" kern="1200" dirty="0">
+                <a:solidFill>
+                  <a:schemeClr val="tx1"/>
+                </a:solidFill>
+                <a:effectLst/>
+                <a:latin typeface="+mn-lt"/>
+                <a:ea typeface="+mn-ea"/>
+                <a:cs typeface="+mn-cs"/>
+              </a:rPr>
+              <a:t>Giustifica teoricamente l'ottenimento di onde a polarizzazione ellittica e circolare tramite riflessione su specchi metallici</a:t>
+            </a:r>
+            <a:endParaRPr lang="it-IT" dirty="0"/>
           </a:p>
         </p:txBody>
       </p:sp>
@@ -1191,6 +1536,111 @@
             <a:fld id="{366E33DB-1271-41E7-A265-E1E1DFEF3771}" type="slidenum">
               <a:rPr lang="it-IT" smtClean="0"/>
               <a:t>21</a:t>
+            </a:fld>
+            <a:endParaRPr lang="it-IT"/>
+          </a:p>
+        </p:txBody>
+      </p:sp>
+    </p:spTree>
+    <p:extLst>
+      <p:ext uri="{BB962C8B-B14F-4D97-AF65-F5344CB8AC3E}">
+        <p14:creationId xmlns:p14="http://schemas.microsoft.com/office/powerpoint/2010/main" val="2264837903"/>
+      </p:ext>
+    </p:extLst>
+  </p:cSld>
+  <p:clrMapOvr>
+    <a:masterClrMapping/>
+  </p:clrMapOvr>
+</p:notes>
+</file>
+
+<file path=ppt/notesSlides/notesSlide17.xml><?xml version="1.0" encoding="utf-8"?>
+<p:notes xmlns:a="http://schemas.openxmlformats.org/drawingml/2006/main" xmlns:r="http://schemas.openxmlformats.org/officeDocument/2006/relationships" xmlns:p="http://schemas.openxmlformats.org/presentationml/2006/main">
+  <p:cSld>
+    <p:spTree>
+      <p:nvGrpSpPr>
+        <p:cNvPr id="1" name=""/>
+        <p:cNvGrpSpPr/>
+        <p:nvPr/>
+      </p:nvGrpSpPr>
+      <p:grpSpPr>
+        <a:xfrm>
+          <a:off x="0" y="0"/>
+          <a:ext cx="0" cy="0"/>
+          <a:chOff x="0" y="0"/>
+          <a:chExt cx="0" cy="0"/>
+        </a:xfrm>
+      </p:grpSpPr>
+      <p:sp>
+        <p:nvSpPr>
+          <p:cNvPr id="2" name="Segnaposto immagine diapositiva 1"/>
+          <p:cNvSpPr>
+            <a:spLocks noGrp="1" noRot="1" noChangeAspect="1"/>
+          </p:cNvSpPr>
+          <p:nvPr>
+            <p:ph type="sldImg"/>
+          </p:nvPr>
+        </p:nvSpPr>
+        <p:spPr/>
+      </p:sp>
+      <p:sp>
+        <p:nvSpPr>
+          <p:cNvPr id="3" name="Segnaposto note 2"/>
+          <p:cNvSpPr>
+            <a:spLocks noGrp="1"/>
+          </p:cNvSpPr>
+          <p:nvPr>
+            <p:ph type="body" idx="1"/>
+          </p:nvPr>
+        </p:nvSpPr>
+        <p:spPr/>
+        <p:txBody>
+          <a:bodyPr/>
+          <a:lstStyle/>
+          <a:p>
+            <a:r>
+              <a:rPr lang="it-IT" dirty="0"/>
+              <a:t>Pag. 260 del .pdf</a:t>
+            </a:r>
+          </a:p>
+          <a:p>
+            <a:endParaRPr lang="it-IT" dirty="0"/>
+          </a:p>
+          <a:p>
+            <a:r>
+              <a:rPr lang="it-IT" sz="1200" b="0" kern="1200" dirty="0">
+                <a:solidFill>
+                  <a:schemeClr val="tx1"/>
+                </a:solidFill>
+                <a:effectLst/>
+                <a:latin typeface="+mn-lt"/>
+                <a:ea typeface="+mn-ea"/>
+                <a:cs typeface="+mn-cs"/>
+              </a:rPr>
+              <a:t>Collegamento con i capitoli: Si collega al Capitolo V (§ 43), al Capitolo VI (§ 48-49, polarizzazione per riflessione totale) e al Capitolo VII (§ 53-54, polarizzazione ellittica in lamine di selenite/gesso) della Parte Seconda</a:t>
+            </a:r>
+            <a:endParaRPr lang="it-IT" b="0" dirty="0"/>
+          </a:p>
+        </p:txBody>
+      </p:sp>
+      <p:sp>
+        <p:nvSpPr>
+          <p:cNvPr id="4" name="Segnaposto numero diapositiva 3"/>
+          <p:cNvSpPr>
+            <a:spLocks noGrp="1"/>
+          </p:cNvSpPr>
+          <p:nvPr>
+            <p:ph type="sldNum" sz="quarter" idx="5"/>
+          </p:nvPr>
+        </p:nvSpPr>
+        <p:spPr/>
+        <p:txBody>
+          <a:bodyPr/>
+          <a:lstStyle/>
+          <a:p>
+            <a:fld id="{366E33DB-1271-41E7-A265-E1E1DFEF3771}" type="slidenum">
+              <a:rPr lang="it-IT" smtClean="0"/>
+              <a:t>22</a:t>
             </a:fld>
             <a:endParaRPr lang="it-IT"/>
           </a:p>
@@ -1214,7 +1664,13 @@
   <p:cSld>
     <p:spTree>
       <p:nvGrpSpPr>
-        <p:cNvPr id="1" name=""/>
+        <p:cNvPr id="1" name="">
+          <a:extLst>
+            <a:ext uri="{FF2B5EF4-FFF2-40B4-BE49-F238E27FC236}">
+              <a16:creationId xmlns:a16="http://schemas.microsoft.com/office/drawing/2014/main" id="{452632B8-A58F-0501-E1EB-20E4689B1CDA}"/>
+            </a:ext>
+          </a:extLst>
+        </p:cNvPr>
         <p:cNvGrpSpPr/>
         <p:nvPr/>
       </p:nvGrpSpPr>
@@ -1228,7 +1684,13 @@
       </p:grpSpPr>
       <p:sp>
         <p:nvSpPr>
-          <p:cNvPr id="2" name="Segnaposto immagine diapositiva 1"/>
+          <p:cNvPr id="2" name="Segnaposto immagine diapositiva 1">
+            <a:extLst>
+              <a:ext uri="{FF2B5EF4-FFF2-40B4-BE49-F238E27FC236}">
+                <a16:creationId xmlns:a16="http://schemas.microsoft.com/office/drawing/2014/main" id="{D39482DD-F478-13C4-E107-2D35229DC020}"/>
+              </a:ext>
+            </a:extLst>
+          </p:cNvPr>
           <p:cNvSpPr>
             <a:spLocks noGrp="1" noRot="1" noChangeAspect="1"/>
           </p:cNvSpPr>
@@ -1240,7 +1702,13 @@
       </p:sp>
       <p:sp>
         <p:nvSpPr>
-          <p:cNvPr id="3" name="Segnaposto note 2"/>
+          <p:cNvPr id="3" name="Segnaposto note 2">
+            <a:extLst>
+              <a:ext uri="{FF2B5EF4-FFF2-40B4-BE49-F238E27FC236}">
+                <a16:creationId xmlns:a16="http://schemas.microsoft.com/office/drawing/2014/main" id="{C22D58E7-9940-8C3B-8B69-2EB92B38B88D}"/>
+              </a:ext>
+            </a:extLst>
+          </p:cNvPr>
           <p:cNvSpPr>
             <a:spLocks noGrp="1"/>
           </p:cNvSpPr>
@@ -1253,16 +1721,57 @@
           <a:bodyPr/>
           <a:lstStyle/>
           <a:p>
-            <a:r>
-              <a:rPr lang="it-IT" dirty="0"/>
-              <a:t>Pag. 41 del .pdf</a:t>
-            </a:r>
-          </a:p>
-        </p:txBody>
-      </p:sp>
-      <p:sp>
-        <p:nvSpPr>
-          <p:cNvPr id="4" name="Segnaposto numero diapositiva 3"/>
+            <a:pPr rtl="0"/>
+            <a:r>
+              <a:rPr lang="it-IT" dirty="0"/>
+              <a:t>Pag.  16 (33 del .pdf) </a:t>
+            </a:r>
+            <a:r>
+              <a:rPr lang="it-IT" dirty="0">
+                <a:sym typeface="Wingdings" panose="05000000000000000000" pitchFamily="2" charset="2"/>
+              </a:rPr>
+              <a:t> inizia a parlare di risonatori (parla di quelli di Hertz e dice che dopo di lui ne sono stati inventati diversi)</a:t>
+            </a:r>
+            <a:br>
+              <a:rPr lang="it-IT" dirty="0">
+                <a:sym typeface="Wingdings" panose="05000000000000000000" pitchFamily="2" charset="2"/>
+              </a:rPr>
+            </a:br>
+            <a:br>
+              <a:rPr lang="it-IT" dirty="0">
+                <a:sym typeface="Wingdings" panose="05000000000000000000" pitchFamily="2" charset="2"/>
+              </a:rPr>
+            </a:br>
+            <a:r>
+              <a:rPr lang="it-IT" dirty="0">
+                <a:sym typeface="Wingdings" panose="05000000000000000000" pitchFamily="2" charset="2"/>
+              </a:rPr>
+              <a:t>pag. 18 (35 del .pdf)  parla dei risonatori in vetro e argento</a:t>
+            </a:r>
+            <a:endParaRPr lang="it-IT" dirty="0"/>
+          </a:p>
+          <a:p>
+            <a:pPr rtl="0"/>
+            <a:endParaRPr lang="it-IT" dirty="0"/>
+          </a:p>
+          <a:p>
+            <a:pPr rtl="0"/>
+            <a:endParaRPr lang="it-IT" dirty="0"/>
+          </a:p>
+          <a:p>
+            <a:endParaRPr lang="it-IT" dirty="0"/>
+          </a:p>
+        </p:txBody>
+      </p:sp>
+      <p:sp>
+        <p:nvSpPr>
+          <p:cNvPr id="4" name="Segnaposto numero diapositiva 3">
+            <a:extLst>
+              <a:ext uri="{FF2B5EF4-FFF2-40B4-BE49-F238E27FC236}">
+                <a16:creationId xmlns:a16="http://schemas.microsoft.com/office/drawing/2014/main" id="{1209103C-5226-2598-1389-7399C0DF7204}"/>
+              </a:ext>
+            </a:extLst>
+          </p:cNvPr>
           <p:cNvSpPr>
             <a:spLocks noGrp="1"/>
           </p:cNvSpPr>
@@ -1286,7 +1795,7 @@
     </p:spTree>
     <p:extLst>
       <p:ext uri="{BB962C8B-B14F-4D97-AF65-F5344CB8AC3E}">
-        <p14:creationId xmlns:p14="http://schemas.microsoft.com/office/powerpoint/2010/main" val="2777261984"/>
+        <p14:creationId xmlns:p14="http://schemas.microsoft.com/office/powerpoint/2010/main" val="3970617075"/>
       </p:ext>
     </p:extLst>
   </p:cSld>
@@ -1341,141 +1850,9 @@
           <a:lstStyle/>
           <a:p>
             <a:r>
-              <a:rPr lang="it-IT" b="1" dirty="0"/>
-              <a:t>Lunghezza del risonatore</a:t>
-            </a:r>
-            <a:r>
-              <a:rPr lang="it-IT" dirty="0"/>
-              <a:t>: indica la lunghezza orizzontale della striscia d'argento (espressa in centimetri: ad esempio 0.9 cm, 3.6 cm o 10 cm).</a:t>
-            </a:r>
-            <a:r>
-              <a:rPr lang="it-IT" sz="1200" kern="1200" dirty="0">
-                <a:solidFill>
-                  <a:schemeClr val="tx1"/>
-                </a:solidFill>
-                <a:effectLst/>
-                <a:latin typeface="+mn-lt"/>
-                <a:ea typeface="+mn-ea"/>
-                <a:cs typeface="+mn-cs"/>
-              </a:rPr>
-              <a:t> Questa dimensione è il fattore principale che determina la frequenza di risonanza dello strumento e corrisponde indicativamente a </a:t>
-            </a:r>
-            <a:r>
-              <a:rPr lang="it-IT" sz="1200" b="1" kern="1200" dirty="0">
-                <a:solidFill>
-                  <a:schemeClr val="tx1"/>
-                </a:solidFill>
-                <a:effectLst/>
-                <a:latin typeface="+mn-lt"/>
-                <a:ea typeface="+mn-ea"/>
-                <a:cs typeface="+mn-cs"/>
-              </a:rPr>
-              <a:t>metà della lunghezza d'onda (lambda/2).</a:t>
-            </a:r>
-            <a:br>
-              <a:rPr lang="it-IT" sz="1200" b="1" kern="1200" dirty="0">
-                <a:solidFill>
-                  <a:schemeClr val="tx1"/>
-                </a:solidFill>
-                <a:effectLst/>
-                <a:latin typeface="+mn-lt"/>
-                <a:ea typeface="+mn-ea"/>
-                <a:cs typeface="+mn-cs"/>
-              </a:rPr>
-            </a:br>
-            <a:br>
-              <a:rPr lang="it-IT" sz="1200" b="1" kern="1200" dirty="0">
-                <a:solidFill>
-                  <a:schemeClr val="tx1"/>
-                </a:solidFill>
-                <a:effectLst/>
-                <a:latin typeface="+mn-lt"/>
-                <a:ea typeface="+mn-ea"/>
-                <a:cs typeface="+mn-cs"/>
-              </a:rPr>
-            </a:br>
-            <a:r>
-              <a:rPr lang="it-IT" sz="1200" b="1" kern="1200" dirty="0">
-                <a:solidFill>
-                  <a:schemeClr val="tx1"/>
-                </a:solidFill>
-                <a:effectLst/>
-                <a:latin typeface="+mn-lt"/>
-                <a:ea typeface="+mn-ea"/>
-                <a:cs typeface="+mn-cs"/>
-              </a:rPr>
-              <a:t>Larghezza del risonatore</a:t>
-            </a:r>
-            <a:r>
-              <a:rPr lang="it-IT" sz="1200" kern="1200" dirty="0">
-                <a:solidFill>
-                  <a:schemeClr val="tx1"/>
-                </a:solidFill>
-                <a:effectLst/>
-                <a:latin typeface="+mn-lt"/>
-                <a:ea typeface="+mn-ea"/>
-                <a:cs typeface="+mn-cs"/>
-              </a:rPr>
-              <a:t>: indica la larghezza della listerella di vetro/argento tagliata dalla lastra (espressa in centimetri: ad esempio 0,1 cm, 0,2 cm o 0,6 cm). </a:t>
-            </a:r>
-            <a:br>
-              <a:rPr lang="it-IT" sz="1200" kern="1200" dirty="0">
-                <a:solidFill>
-                  <a:schemeClr val="tx1"/>
-                </a:solidFill>
-                <a:effectLst/>
-                <a:latin typeface="+mn-lt"/>
-                <a:ea typeface="+mn-ea"/>
-                <a:cs typeface="+mn-cs"/>
-              </a:rPr>
-            </a:br>
-            <a:r>
-              <a:rPr lang="it-IT" sz="1200" kern="1200" dirty="0">
-                <a:solidFill>
-                  <a:schemeClr val="tx1"/>
-                </a:solidFill>
-                <a:effectLst/>
-                <a:latin typeface="+mn-lt"/>
-                <a:ea typeface="+mn-ea"/>
-                <a:cs typeface="+mn-cs"/>
-              </a:rPr>
-              <a:t>Righi spiega che la larghezza agisce in modo analogo alla sezione di un tubo sonoro: mantenendo costante la lunghezza, all'aumentare della larghezza aumenta leggermente la lunghezza d'onda dell'oscillazione.</a:t>
-            </a:r>
-            <a:br>
-              <a:rPr lang="it-IT" sz="1200" kern="1200" dirty="0">
-                <a:solidFill>
-                  <a:schemeClr val="tx1"/>
-                </a:solidFill>
-                <a:effectLst/>
-                <a:latin typeface="+mn-lt"/>
-                <a:ea typeface="+mn-ea"/>
-                <a:cs typeface="+mn-cs"/>
-              </a:rPr>
-            </a:br>
-            <a:br>
-              <a:rPr lang="it-IT" sz="1200" kern="1200" dirty="0">
-                <a:solidFill>
-                  <a:schemeClr val="tx1"/>
-                </a:solidFill>
-                <a:effectLst/>
-                <a:latin typeface="+mn-lt"/>
-                <a:ea typeface="+mn-ea"/>
-                <a:cs typeface="+mn-cs"/>
-              </a:rPr>
-            </a:br>
-            <a:r>
-              <a:rPr lang="it-IT" sz="1200" kern="1200" dirty="0">
-                <a:solidFill>
-                  <a:schemeClr val="tx1"/>
-                </a:solidFill>
-                <a:effectLst/>
-                <a:latin typeface="+mn-lt"/>
-                <a:ea typeface="+mn-ea"/>
-                <a:cs typeface="+mn-cs"/>
-              </a:rPr>
-              <a:t>Pag. 45 del .pdf</a:t>
-            </a:r>
-            <a:endParaRPr lang="it-IT" dirty="0"/>
+              <a:rPr lang="it-IT" dirty="0"/>
+              <a:t>Pag. 41 del .pdf</a:t>
+            </a:r>
           </a:p>
         </p:txBody>
       </p:sp>
@@ -1505,7 +1882,7 @@
     </p:spTree>
     <p:extLst>
       <p:ext uri="{BB962C8B-B14F-4D97-AF65-F5344CB8AC3E}">
-        <p14:creationId xmlns:p14="http://schemas.microsoft.com/office/powerpoint/2010/main" val="1652414151"/>
+        <p14:creationId xmlns:p14="http://schemas.microsoft.com/office/powerpoint/2010/main" val="2777261984"/>
       </p:ext>
     </p:extLst>
   </p:cSld>
@@ -1559,29 +1936,142 @@
           <a:bodyPr/>
           <a:lstStyle/>
           <a:p>
-            <a:pPr algn="just"/>
             <a:r>
               <a:rPr lang="it-IT" b="1" dirty="0"/>
-              <a:t>Parte 2 – </a:t>
-            </a:r>
-            <a:r>
-              <a:rPr lang="it-IT" b="0" dirty="0"/>
-              <a:t>pag. 90 del .pdf</a:t>
-            </a:r>
-            <a:endParaRPr lang="it-IT" b="1" dirty="0"/>
-          </a:p>
-          <a:p>
+              <a:t>Lunghezza del risonatore</a:t>
+            </a:r>
+            <a:r>
+              <a:rPr lang="it-IT" dirty="0"/>
+              <a:t>: indica la lunghezza orizzontale della striscia d'argento (espressa in centimetri: ad esempio 0.9 cm, 3.6 cm o 10 cm).</a:t>
+            </a:r>
+            <a:r>
+              <a:rPr lang="it-IT" sz="1200" kern="1200" dirty="0">
+                <a:solidFill>
+                  <a:schemeClr val="tx1"/>
+                </a:solidFill>
+                <a:effectLst/>
+                <a:latin typeface="+mn-lt"/>
+                <a:ea typeface="+mn-ea"/>
+                <a:cs typeface="+mn-cs"/>
+              </a:rPr>
+              <a:t> Questa dimensione è il fattore principale che determina la frequenza di risonanza dello strumento e corrisponde indicativamente a </a:t>
+            </a:r>
+            <a:r>
+              <a:rPr lang="it-IT" sz="1200" b="1" kern="1200" dirty="0">
+                <a:solidFill>
+                  <a:schemeClr val="tx1"/>
+                </a:solidFill>
+                <a:effectLst/>
+                <a:latin typeface="+mn-lt"/>
+                <a:ea typeface="+mn-ea"/>
+                <a:cs typeface="+mn-cs"/>
+              </a:rPr>
+              <a:t>metà della lunghezza d'onda (lambda/2).</a:t>
+            </a:r>
+            <a:br>
+              <a:rPr lang="it-IT" sz="1200" b="1" kern="1200" dirty="0">
+                <a:solidFill>
+                  <a:schemeClr val="tx1"/>
+                </a:solidFill>
+                <a:effectLst/>
+                <a:latin typeface="+mn-lt"/>
+                <a:ea typeface="+mn-ea"/>
+                <a:cs typeface="+mn-cs"/>
+              </a:rPr>
+            </a:br>
+            <a:br>
+              <a:rPr lang="it-IT" sz="1200" b="1" kern="1200" dirty="0">
+                <a:solidFill>
+                  <a:schemeClr val="tx1"/>
+                </a:solidFill>
+                <a:effectLst/>
+                <a:latin typeface="+mn-lt"/>
+                <a:ea typeface="+mn-ea"/>
+                <a:cs typeface="+mn-cs"/>
+              </a:rPr>
+            </a:br>
+            <a:r>
+              <a:rPr lang="it-IT" sz="1200" b="1" kern="1200" dirty="0">
+                <a:solidFill>
+                  <a:schemeClr val="tx1"/>
+                </a:solidFill>
+                <a:effectLst/>
+                <a:latin typeface="+mn-lt"/>
+                <a:ea typeface="+mn-ea"/>
+                <a:cs typeface="+mn-cs"/>
+              </a:rPr>
+              <a:t>Larghezza del risonatore</a:t>
+            </a:r>
+            <a:r>
+              <a:rPr lang="it-IT" sz="1200" kern="1200" dirty="0">
+                <a:solidFill>
+                  <a:schemeClr val="tx1"/>
+                </a:solidFill>
+                <a:effectLst/>
+                <a:latin typeface="+mn-lt"/>
+                <a:ea typeface="+mn-ea"/>
+                <a:cs typeface="+mn-cs"/>
+              </a:rPr>
+              <a:t>: indica la larghezza della listerella di vetro/argento tagliata dalla lastra (espressa in centimetri: ad esempio 0,1 cm, 0,2 cm o 0,6 cm). </a:t>
+            </a:r>
+            <a:br>
+              <a:rPr lang="it-IT" sz="1200" kern="1200" dirty="0">
+                <a:solidFill>
+                  <a:schemeClr val="tx1"/>
+                </a:solidFill>
+                <a:effectLst/>
+                <a:latin typeface="+mn-lt"/>
+                <a:ea typeface="+mn-ea"/>
+                <a:cs typeface="+mn-cs"/>
+              </a:rPr>
+            </a:br>
+            <a:r>
+              <a:rPr lang="it-IT" sz="1200" kern="1200" dirty="0">
+                <a:solidFill>
+                  <a:schemeClr val="tx1"/>
+                </a:solidFill>
+                <a:effectLst/>
+                <a:latin typeface="+mn-lt"/>
+                <a:ea typeface="+mn-ea"/>
+                <a:cs typeface="+mn-cs"/>
+              </a:rPr>
+              <a:t>Righi spiega che la larghezza agisce in modo analogo alla sezione di un tubo sonoro: mantenendo costante la lunghezza, all'aumentare della larghezza aumenta leggermente la lunghezza d'onda dell'oscillazione.</a:t>
+            </a:r>
+            <a:br>
+              <a:rPr lang="it-IT" sz="1200" kern="1200" dirty="0">
+                <a:solidFill>
+                  <a:schemeClr val="tx1"/>
+                </a:solidFill>
+                <a:effectLst/>
+                <a:latin typeface="+mn-lt"/>
+                <a:ea typeface="+mn-ea"/>
+                <a:cs typeface="+mn-cs"/>
+              </a:rPr>
+            </a:br>
+            <a:br>
+              <a:rPr lang="it-IT" sz="1200" kern="1200" dirty="0">
+                <a:solidFill>
+                  <a:schemeClr val="tx1"/>
+                </a:solidFill>
+                <a:effectLst/>
+                <a:latin typeface="+mn-lt"/>
+                <a:ea typeface="+mn-ea"/>
+                <a:cs typeface="+mn-cs"/>
+              </a:rPr>
+            </a:br>
+            <a:r>
+              <a:rPr lang="it-IT" sz="1200" kern="1200" dirty="0">
+                <a:solidFill>
+                  <a:schemeClr val="tx1"/>
+                </a:solidFill>
+                <a:effectLst/>
+                <a:latin typeface="+mn-lt"/>
+                <a:ea typeface="+mn-ea"/>
+                <a:cs typeface="+mn-cs"/>
+              </a:rPr>
+              <a:t>Pag. 45 del .pdf</a:t>
+            </a:r>
             <a:endParaRPr lang="it-IT" dirty="0"/>
-          </a:p>
-          <a:p>
-            <a:r>
-              <a:rPr lang="it-IT" dirty="0" err="1"/>
-              <a:t>Pag</a:t>
-            </a:r>
-            <a:r>
-              <a:rPr lang="it-IT" dirty="0"/>
-              <a:t> 92 del .pdf</a:t>
-            </a:r>
           </a:p>
         </p:txBody>
       </p:sp>
@@ -1602,7 +2092,7 @@
           <a:p>
             <a:fld id="{366E33DB-1271-41E7-A265-E1E1DFEF3771}" type="slidenum">
               <a:rPr lang="it-IT" smtClean="0"/>
-              <a:t>9</a:t>
+              <a:t>7</a:t>
             </a:fld>
             <a:endParaRPr lang="it-IT"/>
           </a:p>
@@ -1611,7 +2101,7 @@
     </p:spTree>
     <p:extLst>
       <p:ext uri="{BB962C8B-B14F-4D97-AF65-F5344CB8AC3E}">
-        <p14:creationId xmlns:p14="http://schemas.microsoft.com/office/powerpoint/2010/main" val="590232562"/>
+        <p14:creationId xmlns:p14="http://schemas.microsoft.com/office/powerpoint/2010/main" val="1652414151"/>
       </p:ext>
     </p:extLst>
   </p:cSld>
@@ -1665,9 +2155,28 @@
           <a:bodyPr/>
           <a:lstStyle/>
           <a:p>
-            <a:r>
-              <a:rPr lang="it-IT" dirty="0"/>
-              <a:t>Pag. 114 del .pdf</a:t>
+            <a:pPr algn="just"/>
+            <a:r>
+              <a:rPr lang="it-IT" b="1" dirty="0"/>
+              <a:t>Parte 2 – </a:t>
+            </a:r>
+            <a:r>
+              <a:rPr lang="it-IT" b="0" dirty="0"/>
+              <a:t>pag. 90 del .pdf</a:t>
+            </a:r>
+            <a:endParaRPr lang="it-IT" b="1" dirty="0"/>
+          </a:p>
+          <a:p>
+            <a:endParaRPr lang="it-IT" dirty="0"/>
+          </a:p>
+          <a:p>
+            <a:r>
+              <a:rPr lang="it-IT" dirty="0" err="1"/>
+              <a:t>Pag</a:t>
+            </a:r>
+            <a:r>
+              <a:rPr lang="it-IT" dirty="0"/>
+              <a:t> 92 del .pdf</a:t>
             </a:r>
           </a:p>
         </p:txBody>
@@ -1698,7 +2207,7 @@
     </p:spTree>
     <p:extLst>
       <p:ext uri="{BB962C8B-B14F-4D97-AF65-F5344CB8AC3E}">
-        <p14:creationId xmlns:p14="http://schemas.microsoft.com/office/powerpoint/2010/main" val="559134702"/>
+        <p14:creationId xmlns:p14="http://schemas.microsoft.com/office/powerpoint/2010/main" val="590232562"/>
       </p:ext>
     </p:extLst>
   </p:cSld>
@@ -1753,12 +2262,8 @@
           <a:lstStyle/>
           <a:p>
             <a:r>
-              <a:rPr lang="it-IT" dirty="0" err="1"/>
-              <a:t>pag</a:t>
-            </a:r>
-            <a:r>
-              <a:rPr lang="it-IT" dirty="0"/>
-              <a:t> 120 del .pdf</a:t>
+              <a:rPr lang="it-IT" dirty="0"/>
+              <a:t>Pag. 114 del .pdf</a:t>
             </a:r>
           </a:p>
         </p:txBody>
@@ -1789,7 +2294,7 @@
     </p:spTree>
     <p:extLst>
       <p:ext uri="{BB962C8B-B14F-4D97-AF65-F5344CB8AC3E}">
-        <p14:creationId xmlns:p14="http://schemas.microsoft.com/office/powerpoint/2010/main" val="2922921113"/>
+        <p14:creationId xmlns:p14="http://schemas.microsoft.com/office/powerpoint/2010/main" val="559134702"/>
       </p:ext>
     </p:extLst>
   </p:cSld>
@@ -1845,11 +2350,11 @@
           <a:p>
             <a:r>
               <a:rPr lang="it-IT" dirty="0" err="1"/>
-              <a:t>Pag</a:t>
-            </a:r>
-            <a:r>
-              <a:rPr lang="it-IT" dirty="0"/>
-              <a:t> 137 del .pdf</a:t>
+              <a:t>pag</a:t>
+            </a:r>
+            <a:r>
+              <a:rPr lang="it-IT" dirty="0"/>
+              <a:t> 120 del .pdf</a:t>
             </a:r>
           </a:p>
         </p:txBody>
@@ -1880,7 +2385,7 @@
     </p:spTree>
     <p:extLst>
       <p:ext uri="{BB962C8B-B14F-4D97-AF65-F5344CB8AC3E}">
-        <p14:creationId xmlns:p14="http://schemas.microsoft.com/office/powerpoint/2010/main" val="1037071297"/>
+        <p14:creationId xmlns:p14="http://schemas.microsoft.com/office/powerpoint/2010/main" val="2922921113"/>
       </p:ext>
     </p:extLst>
   </p:cSld>
@@ -1940,7 +2445,7 @@
             </a:r>
             <a:r>
               <a:rPr lang="it-IT" dirty="0"/>
-              <a:t> 148 del .pdf</a:t>
+              <a:t> 137 del .pdf</a:t>
             </a:r>
           </a:p>
         </p:txBody>
@@ -1971,7 +2476,7 @@
     </p:spTree>
     <p:extLst>
       <p:ext uri="{BB962C8B-B14F-4D97-AF65-F5344CB8AC3E}">
-        <p14:creationId xmlns:p14="http://schemas.microsoft.com/office/powerpoint/2010/main" val="1537060456"/>
+        <p14:creationId xmlns:p14="http://schemas.microsoft.com/office/powerpoint/2010/main" val="1037071297"/>
       </p:ext>
     </p:extLst>
   </p:cSld>
@@ -2031,7 +2536,7 @@
             </a:r>
             <a:r>
               <a:rPr lang="it-IT" dirty="0"/>
-              <a:t> 170 del .pdf</a:t>
+              <a:t> 148 del .pdf</a:t>
             </a:r>
           </a:p>
         </p:txBody>
@@ -2062,7 +2567,7 @@
     </p:spTree>
     <p:extLst>
       <p:ext uri="{BB962C8B-B14F-4D97-AF65-F5344CB8AC3E}">
-        <p14:creationId xmlns:p14="http://schemas.microsoft.com/office/powerpoint/2010/main" val="152549240"/>
+        <p14:creationId xmlns:p14="http://schemas.microsoft.com/office/powerpoint/2010/main" val="1537060456"/>
       </p:ext>
     </p:extLst>
   </p:cSld>
@@ -2211,7 +2716,7 @@
           <a:p>
             <a:fld id="{48A87A34-81AB-432B-8DAE-1953F412C126}" type="datetimeFigureOut">
               <a:rPr lang="en-US" dirty="0"/>
-              <a:t>10/9/2026</a:t>
+              <a:t>10/11/2026</a:t>
             </a:fld>
             <a:endParaRPr lang="en-US" dirty="0"/>
           </a:p>
@@ -2417,7 +2922,7 @@
           <a:p>
             <a:fld id="{48A87A34-81AB-432B-8DAE-1953F412C126}" type="datetimeFigureOut">
               <a:rPr lang="en-US" dirty="0"/>
-              <a:t>10/9/2026</a:t>
+              <a:t>10/11/2026</a:t>
             </a:fld>
             <a:endParaRPr lang="en-US" dirty="0"/>
           </a:p>
@@ -2627,7 +3132,7 @@
           <a:p>
             <a:fld id="{48A87A34-81AB-432B-8DAE-1953F412C126}" type="datetimeFigureOut">
               <a:rPr lang="en-US" dirty="0"/>
-              <a:t>10/9/2026</a:t>
+              <a:t>10/11/2026</a:t>
             </a:fld>
             <a:endParaRPr lang="en-US" dirty="0"/>
           </a:p>
@@ -2823,7 +3328,7 @@
           <a:p>
             <a:fld id="{48A87A34-81AB-432B-8DAE-1953F412C126}" type="datetimeFigureOut">
               <a:rPr lang="en-US" dirty="0"/>
-              <a:t>10/9/2026</a:t>
+              <a:t>10/11/2026</a:t>
             </a:fld>
             <a:endParaRPr lang="en-US" dirty="0"/>
           </a:p>
@@ -3097,7 +3602,7 @@
           <a:p>
             <a:fld id="{48A87A34-81AB-432B-8DAE-1953F412C126}" type="datetimeFigureOut">
               <a:rPr lang="en-US" dirty="0"/>
-              <a:t>10/9/2026</a:t>
+              <a:t>10/11/2026</a:t>
             </a:fld>
             <a:endParaRPr lang="en-US" dirty="0"/>
           </a:p>
@@ -3360,7 +3865,7 @@
           <a:p>
             <a:fld id="{48A87A34-81AB-432B-8DAE-1953F412C126}" type="datetimeFigureOut">
               <a:rPr lang="en-US" dirty="0"/>
-              <a:t>10/9/2026</a:t>
+              <a:t>10/11/2026</a:t>
             </a:fld>
             <a:endParaRPr lang="en-US" dirty="0"/>
           </a:p>
@@ -3771,7 +4276,7 @@
           <a:p>
             <a:fld id="{48A87A34-81AB-432B-8DAE-1953F412C126}" type="datetimeFigureOut">
               <a:rPr lang="en-US" dirty="0"/>
-              <a:t>10/9/2026</a:t>
+              <a:t>10/11/2026</a:t>
             </a:fld>
             <a:endParaRPr lang="en-US" dirty="0"/>
           </a:p>
@@ -3915,7 +4420,7 @@
           <a:p>
             <a:fld id="{48A87A34-81AB-432B-8DAE-1953F412C126}" type="datetimeFigureOut">
               <a:rPr lang="en-US" dirty="0"/>
-              <a:t>10/9/2026</a:t>
+              <a:t>10/11/2026</a:t>
             </a:fld>
             <a:endParaRPr lang="en-US" dirty="0"/>
           </a:p>
@@ -4036,7 +4541,7 @@
           <a:p>
             <a:fld id="{48A87A34-81AB-432B-8DAE-1953F412C126}" type="datetimeFigureOut">
               <a:rPr lang="en-US" dirty="0"/>
-              <a:t>10/9/2026</a:t>
+              <a:t>10/11/2026</a:t>
             </a:fld>
             <a:endParaRPr lang="en-US" dirty="0"/>
           </a:p>
@@ -4282,7 +4787,7 @@
           <a:p>
             <a:fld id="{48A87A34-81AB-432B-8DAE-1953F412C126}" type="datetimeFigureOut">
               <a:rPr lang="en-US" dirty="0"/>
-              <a:t>10/9/2026</a:t>
+              <a:t>10/11/2026</a:t>
             </a:fld>
             <a:endParaRPr lang="en-US" dirty="0"/>
           </a:p>
@@ -4719,7 +5224,7 @@
             <a:fld id="{48A87A34-81AB-432B-8DAE-1953F412C126}" type="datetimeFigureOut">
               <a:rPr lang="en-US" dirty="0"/>
               <a:pPr/>
-              <a:t>10/9/2026</a:t>
+              <a:t>10/11/2026</a:t>
             </a:fld>
             <a:endParaRPr lang="en-US" dirty="0"/>
           </a:p>
@@ -5042,7 +5547,7 @@
             <a:fld id="{48A87A34-81AB-432B-8DAE-1953F412C126}" type="datetimeFigureOut">
               <a:rPr lang="en-US" dirty="0"/>
               <a:pPr/>
-              <a:t>10/9/2026</a:t>
+              <a:t>10/11/2026</a:t>
             </a:fld>
             <a:endParaRPr lang="en-US" dirty="0"/>
           </a:p>
@@ -5572,6 +6077,143 @@
   <p:cSld>
     <p:spTree>
       <p:nvGrpSpPr>
+        <p:cNvPr id="1" name=""/>
+        <p:cNvGrpSpPr/>
+        <p:nvPr/>
+      </p:nvGrpSpPr>
+      <p:grpSpPr>
+        <a:xfrm>
+          <a:off x="0" y="0"/>
+          <a:ext cx="0" cy="0"/>
+          <a:chOff x="0" y="0"/>
+          <a:chExt cx="0" cy="0"/>
+        </a:xfrm>
+      </p:grpSpPr>
+      <p:sp>
+        <p:nvSpPr>
+          <p:cNvPr id="2" name="Titolo 1">
+            <a:extLst>
+              <a:ext uri="{FF2B5EF4-FFF2-40B4-BE49-F238E27FC236}">
+                <a16:creationId xmlns:a16="http://schemas.microsoft.com/office/drawing/2014/main" id="{BE3E8445-21EB-A1C9-7978-31DEC1D65DC8}"/>
+              </a:ext>
+            </a:extLst>
+          </p:cNvPr>
+          <p:cNvSpPr>
+            <a:spLocks noGrp="1"/>
+          </p:cNvSpPr>
+          <p:nvPr>
+            <p:ph type="title"/>
+          </p:nvPr>
+        </p:nvSpPr>
+        <p:spPr/>
+        <p:txBody>
+          <a:bodyPr/>
+          <a:lstStyle/>
+          <a:p>
+            <a:r>
+              <a:rPr lang="it-IT" dirty="0"/>
+              <a:t>Parte 2</a:t>
+            </a:r>
+          </a:p>
+        </p:txBody>
+      </p:sp>
+      <p:sp>
+        <p:nvSpPr>
+          <p:cNvPr id="3" name="Segnaposto contenuto 2">
+            <a:extLst>
+              <a:ext uri="{FF2B5EF4-FFF2-40B4-BE49-F238E27FC236}">
+                <a16:creationId xmlns:a16="http://schemas.microsoft.com/office/drawing/2014/main" id="{5AFE3D66-0521-3272-AB4C-A7B7E9CDB369}"/>
+              </a:ext>
+            </a:extLst>
+          </p:cNvPr>
+          <p:cNvSpPr>
+            <a:spLocks noGrp="1"/>
+          </p:cNvSpPr>
+          <p:nvPr>
+            <p:ph idx="1"/>
+          </p:nvPr>
+        </p:nvSpPr>
+        <p:spPr>
+          <a:xfrm>
+            <a:off x="1451579" y="2015732"/>
+            <a:ext cx="9603275" cy="3851668"/>
+          </a:xfrm>
+        </p:spPr>
+        <p:txBody>
+          <a:bodyPr>
+            <a:normAutofit fontScale="92500" lnSpcReduction="20000"/>
+          </a:bodyPr>
+          <a:lstStyle/>
+          <a:p>
+            <a:r>
+              <a:rPr lang="it-IT" sz="2200" b="1" dirty="0"/>
+              <a:t>Capitolo I – Fenomeni d’interferenza. </a:t>
+            </a:r>
+            <a:br>
+              <a:rPr lang="it-IT" dirty="0"/>
+            </a:br>
+            <a:r>
+              <a:rPr lang="it-IT" dirty="0"/>
+              <a:t>Questo capitolo riproduce in laboratorio le storiche esperienze dell’ottica ondulatoria, adattandole alle onde elettromagnetiche.</a:t>
+            </a:r>
+          </a:p>
+          <a:p>
+            <a:pPr lvl="0"/>
+            <a:r>
+              <a:rPr lang="it-IT" dirty="0"/>
+              <a:t>Onde stazionarie (§ 21): inviando le onde contro uno specchio metallico piano, la sovrapposizione dell’onda incidente e di quella riflessa crea un’onda stazionaria. Facendo scorrere il risonatore si individuano i ventri (massimo scintillio) e i nodi (estinzione delle scintille), permettendo di misurare direttamente la lunghezza d’onda λ.</a:t>
+            </a:r>
+          </a:p>
+          <a:p>
+            <a:pPr lvl="0"/>
+            <a:r>
+              <a:rPr lang="it-IT" dirty="0"/>
+              <a:t>Specchi di Fresnel (§ 22-23) e </a:t>
+            </a:r>
+            <a:r>
+              <a:rPr lang="it-IT" dirty="0" err="1"/>
+              <a:t>biprisma</a:t>
+            </a:r>
+            <a:r>
+              <a:rPr lang="it-IT" dirty="0"/>
+              <a:t> (§ 26): ricreano le classiche disposizioni ottiche di Fresnel utilizzando due specchi metallici inclinati o un </a:t>
+            </a:r>
+            <a:r>
+              <a:rPr lang="it-IT" dirty="0" err="1"/>
+              <a:t>biprisma</a:t>
+            </a:r>
+            <a:r>
+              <a:rPr lang="it-IT" dirty="0"/>
+              <a:t> in paraffina o altro dielettrico, producendo frange d’interferenza osservabili con il risonatore.</a:t>
+            </a:r>
+          </a:p>
+          <a:p>
+            <a:pPr lvl="0"/>
+            <a:r>
+              <a:rPr lang="it-IT" dirty="0"/>
+              <a:t>Determinazione degli indici di rifrazione (§ 24) e interferenza ad uno specchio (§ 25).</a:t>
+            </a:r>
+          </a:p>
+        </p:txBody>
+      </p:sp>
+    </p:spTree>
+    <p:extLst>
+      <p:ext uri="{BB962C8B-B14F-4D97-AF65-F5344CB8AC3E}">
+        <p14:creationId xmlns:p14="http://schemas.microsoft.com/office/powerpoint/2010/main" val="2791653420"/>
+      </p:ext>
+    </p:extLst>
+  </p:cSld>
+  <p:clrMapOvr>
+    <a:masterClrMapping/>
+  </p:clrMapOvr>
+</p:sld>
+</file>
+
+<file path=ppt/slides/slide11.xml><?xml version="1.0" encoding="utf-8"?>
+<p:sld xmlns:a="http://schemas.openxmlformats.org/drawingml/2006/main" xmlns:r="http://schemas.openxmlformats.org/officeDocument/2006/relationships" xmlns:p="http://schemas.openxmlformats.org/presentationml/2006/main">
+  <p:cSld>
+    <p:spTree>
+      <p:nvGrpSpPr>
         <p:cNvPr id="1" name="">
           <a:extLst>
             <a:ext uri="{FF2B5EF4-FFF2-40B4-BE49-F238E27FC236}">
@@ -5680,7 +6322,7 @@
 </p:sld>
 </file>
 
-<file path=ppt/slides/slide11.xml><?xml version="1.0" encoding="utf-8"?>
+<file path=ppt/slides/slide12.xml><?xml version="1.0" encoding="utf-8"?>
 <p:sld xmlns:a="http://schemas.openxmlformats.org/drawingml/2006/main" xmlns:r="http://schemas.openxmlformats.org/officeDocument/2006/relationships" xmlns:p="http://schemas.openxmlformats.org/presentationml/2006/main">
   <p:cSld>
     <p:spTree>
@@ -5800,7 +6442,7 @@
 </p:sld>
 </file>
 
-<file path=ppt/slides/slide12.xml><?xml version="1.0" encoding="utf-8"?>
+<file path=ppt/slides/slide13.xml><?xml version="1.0" encoding="utf-8"?>
 <p:sld xmlns:a="http://schemas.openxmlformats.org/drawingml/2006/main" xmlns:r="http://schemas.openxmlformats.org/officeDocument/2006/relationships" xmlns:p="http://schemas.openxmlformats.org/presentationml/2006/main">
   <p:cSld>
     <p:spTree>
@@ -5925,7 +6567,7 @@
 </p:sld>
 </file>
 
-<file path=ppt/slides/slide13.xml><?xml version="1.0" encoding="utf-8"?>
+<file path=ppt/slides/slide14.xml><?xml version="1.0" encoding="utf-8"?>
 <p:sld xmlns:a="http://schemas.openxmlformats.org/drawingml/2006/main" xmlns:r="http://schemas.openxmlformats.org/officeDocument/2006/relationships" xmlns:p="http://schemas.openxmlformats.org/presentationml/2006/main">
   <p:cSld>
     <p:spTree>
@@ -6048,7 +6690,7 @@
 </p:sld>
 </file>
 
-<file path=ppt/slides/slide14.xml><?xml version="1.0" encoding="utf-8"?>
+<file path=ppt/slides/slide15.xml><?xml version="1.0" encoding="utf-8"?>
 <p:sld xmlns:a="http://schemas.openxmlformats.org/drawingml/2006/main" xmlns:r="http://schemas.openxmlformats.org/officeDocument/2006/relationships" xmlns:p="http://schemas.openxmlformats.org/presentationml/2006/main">
   <p:cSld>
     <p:spTree>
@@ -6200,7 +6842,7 @@
 </p:sld>
 </file>
 
-<file path=ppt/slides/slide15.xml><?xml version="1.0" encoding="utf-8"?>
+<file path=ppt/slides/slide16.xml><?xml version="1.0" encoding="utf-8"?>
 <p:sld xmlns:a="http://schemas.openxmlformats.org/drawingml/2006/main" xmlns:r="http://schemas.openxmlformats.org/officeDocument/2006/relationships" xmlns:p="http://schemas.openxmlformats.org/presentationml/2006/main">
   <p:cSld>
     <p:spTree>
@@ -6362,7 +7004,7 @@
 </p:sld>
 </file>
 
-<file path=ppt/slides/slide16.xml><?xml version="1.0" encoding="utf-8"?>
+<file path=ppt/slides/slide17.xml><?xml version="1.0" encoding="utf-8"?>
 <p:sld xmlns:a="http://schemas.openxmlformats.org/drawingml/2006/main" xmlns:r="http://schemas.openxmlformats.org/officeDocument/2006/relationships" xmlns:p="http://schemas.openxmlformats.org/presentationml/2006/main">
   <p:cSld>
     <p:spTree>
@@ -6495,7 +7137,7 @@
 </p:sld>
 </file>
 
-<file path=ppt/slides/slide17.xml><?xml version="1.0" encoding="utf-8"?>
+<file path=ppt/slides/slide18.xml><?xml version="1.0" encoding="utf-8"?>
 <p:sld xmlns:a="http://schemas.openxmlformats.org/drawingml/2006/main" xmlns:r="http://schemas.openxmlformats.org/officeDocument/2006/relationships" xmlns:p="http://schemas.openxmlformats.org/presentationml/2006/main">
   <p:cSld>
     <p:spTree>
@@ -6623,7 +7265,7 @@
 </p:sld>
 </file>
 
-<file path=ppt/slides/slide18.xml><?xml version="1.0" encoding="utf-8"?>
+<file path=ppt/slides/slide19.xml><?xml version="1.0" encoding="utf-8"?>
 <p:sld xmlns:a="http://schemas.openxmlformats.org/drawingml/2006/main" xmlns:r="http://schemas.openxmlformats.org/officeDocument/2006/relationships" xmlns:p="http://schemas.openxmlformats.org/presentationml/2006/main">
   <p:cSld>
     <p:spTree>
@@ -6739,131 +7381,6 @@
     <p:extLst>
       <p:ext uri="{BB962C8B-B14F-4D97-AF65-F5344CB8AC3E}">
         <p14:creationId xmlns:p14="http://schemas.microsoft.com/office/powerpoint/2010/main" val="926464060"/>
-      </p:ext>
-    </p:extLst>
-  </p:cSld>
-  <p:clrMapOvr>
-    <a:masterClrMapping/>
-  </p:clrMapOvr>
-</p:sld>
-</file>
-
-<file path=ppt/slides/slide19.xml><?xml version="1.0" encoding="utf-8"?>
-<p:sld xmlns:a="http://schemas.openxmlformats.org/drawingml/2006/main" xmlns:r="http://schemas.openxmlformats.org/officeDocument/2006/relationships" xmlns:p="http://schemas.openxmlformats.org/presentationml/2006/main">
-  <p:cSld>
-    <p:spTree>
-      <p:nvGrpSpPr>
-        <p:cNvPr id="1" name="">
-          <a:extLst>
-            <a:ext uri="{FF2B5EF4-FFF2-40B4-BE49-F238E27FC236}">
-              <a16:creationId xmlns:a16="http://schemas.microsoft.com/office/drawing/2014/main" id="{BD41179D-50C9-AD5A-40D3-93666D54715F}"/>
-            </a:ext>
-          </a:extLst>
-        </p:cNvPr>
-        <p:cNvGrpSpPr/>
-        <p:nvPr/>
-      </p:nvGrpSpPr>
-      <p:grpSpPr>
-        <a:xfrm>
-          <a:off x="0" y="0"/>
-          <a:ext cx="0" cy="0"/>
-          <a:chOff x="0" y="0"/>
-          <a:chExt cx="0" cy="0"/>
-        </a:xfrm>
-      </p:grpSpPr>
-      <p:sp>
-        <p:nvSpPr>
-          <p:cNvPr id="2" name="Titolo 1">
-            <a:extLst>
-              <a:ext uri="{FF2B5EF4-FFF2-40B4-BE49-F238E27FC236}">
-                <a16:creationId xmlns:a16="http://schemas.microsoft.com/office/drawing/2014/main" id="{645AA28C-9134-06B0-F161-85AAC4100A61}"/>
-              </a:ext>
-            </a:extLst>
-          </p:cNvPr>
-          <p:cNvSpPr>
-            <a:spLocks noGrp="1"/>
-          </p:cNvSpPr>
-          <p:nvPr>
-            <p:ph type="title"/>
-          </p:nvPr>
-        </p:nvSpPr>
-        <p:spPr/>
-        <p:txBody>
-          <a:bodyPr/>
-          <a:lstStyle/>
-          <a:p>
-            <a:r>
-              <a:rPr lang="it-IT" dirty="0"/>
-              <a:t>Note</a:t>
-            </a:r>
-          </a:p>
-        </p:txBody>
-      </p:sp>
-      <p:sp>
-        <p:nvSpPr>
-          <p:cNvPr id="3" name="Segnaposto contenuto 2">
-            <a:extLst>
-              <a:ext uri="{FF2B5EF4-FFF2-40B4-BE49-F238E27FC236}">
-                <a16:creationId xmlns:a16="http://schemas.microsoft.com/office/drawing/2014/main" id="{CE6D8859-CBA6-6E07-4ECA-40D0F2ECC63F}"/>
-              </a:ext>
-            </a:extLst>
-          </p:cNvPr>
-          <p:cNvSpPr>
-            <a:spLocks noGrp="1"/>
-          </p:cNvSpPr>
-          <p:nvPr>
-            <p:ph idx="1"/>
-          </p:nvPr>
-        </p:nvSpPr>
-        <p:spPr/>
-        <p:txBody>
-          <a:bodyPr>
-            <a:normAutofit/>
-          </a:bodyPr>
-          <a:lstStyle/>
-          <a:p>
-            <a:r>
-              <a:rPr lang="it-IT" b="1" dirty="0"/>
-              <a:t>Nota D –</a:t>
-            </a:r>
-            <a:r>
-              <a:rPr lang="it-IT" dirty="0"/>
-              <a:t> </a:t>
-            </a:r>
-            <a:r>
-              <a:rPr lang="it-IT" b="1" dirty="0"/>
-              <a:t>Sulla riflessione e sulla rifrazione delle onde elettro-magnetiche</a:t>
-            </a:r>
-            <a:endParaRPr lang="it-IT" dirty="0"/>
-          </a:p>
-          <a:p>
-            <a:pPr lvl="0"/>
-            <a:r>
-              <a:rPr lang="it-IT" b="1" dirty="0"/>
-              <a:t>Contenuto</a:t>
-            </a:r>
-            <a:r>
-              <a:rPr lang="it-IT" dirty="0"/>
-              <a:t>: Ricava direttamente dalle equazioni differenziali fondamentali di Hertz e Maxwell le leggi e le formule analitiche della riflessione e della rifrazione.</a:t>
-            </a:r>
-          </a:p>
-          <a:p>
-            <a:pPr lvl="0"/>
-            <a:r>
-              <a:rPr lang="it-IT" b="1" dirty="0"/>
-              <a:t>Significato</a:t>
-            </a:r>
-            <a:r>
-              <a:rPr lang="it-IT" dirty="0"/>
-              <a:t>: Dimostra che le equazioni dell'elettromagnetismo conducono esattamente alle medesime formule dell'ottica classica (equazioni di Fresnel).</a:t>
-            </a:r>
-          </a:p>
-        </p:txBody>
-      </p:sp>
-    </p:spTree>
-    <p:extLst>
-      <p:ext uri="{BB962C8B-B14F-4D97-AF65-F5344CB8AC3E}">
-        <p14:creationId xmlns:p14="http://schemas.microsoft.com/office/powerpoint/2010/main" val="1840846919"/>
       </p:ext>
     </p:extLst>
   </p:cSld>
@@ -7085,6 +7602,131 @@
         <p:cNvPr id="1" name="">
           <a:extLst>
             <a:ext uri="{FF2B5EF4-FFF2-40B4-BE49-F238E27FC236}">
+              <a16:creationId xmlns:a16="http://schemas.microsoft.com/office/drawing/2014/main" id="{BD41179D-50C9-AD5A-40D3-93666D54715F}"/>
+            </a:ext>
+          </a:extLst>
+        </p:cNvPr>
+        <p:cNvGrpSpPr/>
+        <p:nvPr/>
+      </p:nvGrpSpPr>
+      <p:grpSpPr>
+        <a:xfrm>
+          <a:off x="0" y="0"/>
+          <a:ext cx="0" cy="0"/>
+          <a:chOff x="0" y="0"/>
+          <a:chExt cx="0" cy="0"/>
+        </a:xfrm>
+      </p:grpSpPr>
+      <p:sp>
+        <p:nvSpPr>
+          <p:cNvPr id="2" name="Titolo 1">
+            <a:extLst>
+              <a:ext uri="{FF2B5EF4-FFF2-40B4-BE49-F238E27FC236}">
+                <a16:creationId xmlns:a16="http://schemas.microsoft.com/office/drawing/2014/main" id="{645AA28C-9134-06B0-F161-85AAC4100A61}"/>
+              </a:ext>
+            </a:extLst>
+          </p:cNvPr>
+          <p:cNvSpPr>
+            <a:spLocks noGrp="1"/>
+          </p:cNvSpPr>
+          <p:nvPr>
+            <p:ph type="title"/>
+          </p:nvPr>
+        </p:nvSpPr>
+        <p:spPr/>
+        <p:txBody>
+          <a:bodyPr/>
+          <a:lstStyle/>
+          <a:p>
+            <a:r>
+              <a:rPr lang="it-IT" dirty="0"/>
+              <a:t>Note</a:t>
+            </a:r>
+          </a:p>
+        </p:txBody>
+      </p:sp>
+      <p:sp>
+        <p:nvSpPr>
+          <p:cNvPr id="3" name="Segnaposto contenuto 2">
+            <a:extLst>
+              <a:ext uri="{FF2B5EF4-FFF2-40B4-BE49-F238E27FC236}">
+                <a16:creationId xmlns:a16="http://schemas.microsoft.com/office/drawing/2014/main" id="{CE6D8859-CBA6-6E07-4ECA-40D0F2ECC63F}"/>
+              </a:ext>
+            </a:extLst>
+          </p:cNvPr>
+          <p:cNvSpPr>
+            <a:spLocks noGrp="1"/>
+          </p:cNvSpPr>
+          <p:nvPr>
+            <p:ph idx="1"/>
+          </p:nvPr>
+        </p:nvSpPr>
+        <p:spPr/>
+        <p:txBody>
+          <a:bodyPr>
+            <a:normAutofit/>
+          </a:bodyPr>
+          <a:lstStyle/>
+          <a:p>
+            <a:r>
+              <a:rPr lang="it-IT" b="1" dirty="0"/>
+              <a:t>Nota D –</a:t>
+            </a:r>
+            <a:r>
+              <a:rPr lang="it-IT" dirty="0"/>
+              <a:t> </a:t>
+            </a:r>
+            <a:r>
+              <a:rPr lang="it-IT" b="1" dirty="0"/>
+              <a:t>Sulla riflessione e sulla rifrazione delle onde elettro-magnetiche</a:t>
+            </a:r>
+            <a:endParaRPr lang="it-IT" dirty="0"/>
+          </a:p>
+          <a:p>
+            <a:pPr lvl="0"/>
+            <a:r>
+              <a:rPr lang="it-IT" b="1" dirty="0"/>
+              <a:t>Contenuto</a:t>
+            </a:r>
+            <a:r>
+              <a:rPr lang="it-IT" dirty="0"/>
+              <a:t>: Ricava direttamente dalle equazioni differenziali fondamentali di Hertz e Maxwell le leggi e le formule analitiche della riflessione e della rifrazione.</a:t>
+            </a:r>
+          </a:p>
+          <a:p>
+            <a:pPr lvl="0"/>
+            <a:r>
+              <a:rPr lang="it-IT" b="1" dirty="0"/>
+              <a:t>Significato</a:t>
+            </a:r>
+            <a:r>
+              <a:rPr lang="it-IT" dirty="0"/>
+              <a:t>: Dimostra che le equazioni dell'elettromagnetismo conducono esattamente alle medesime formule dell'ottica classica (equazioni di Fresnel).</a:t>
+            </a:r>
+          </a:p>
+        </p:txBody>
+      </p:sp>
+    </p:spTree>
+    <p:extLst>
+      <p:ext uri="{BB962C8B-B14F-4D97-AF65-F5344CB8AC3E}">
+        <p14:creationId xmlns:p14="http://schemas.microsoft.com/office/powerpoint/2010/main" val="1840846919"/>
+      </p:ext>
+    </p:extLst>
+  </p:cSld>
+  <p:clrMapOvr>
+    <a:masterClrMapping/>
+  </p:clrMapOvr>
+</p:sld>
+</file>
+
+<file path=ppt/slides/slide21.xml><?xml version="1.0" encoding="utf-8"?>
+<p:sld xmlns:a="http://schemas.openxmlformats.org/drawingml/2006/main" xmlns:r="http://schemas.openxmlformats.org/officeDocument/2006/relationships" xmlns:p="http://schemas.openxmlformats.org/presentationml/2006/main">
+  <p:cSld>
+    <p:spTree>
+      <p:nvGrpSpPr>
+        <p:cNvPr id="1" name="">
+          <a:extLst>
+            <a:ext uri="{FF2B5EF4-FFF2-40B4-BE49-F238E27FC236}">
               <a16:creationId xmlns:a16="http://schemas.microsoft.com/office/drawing/2014/main" id="{90A5708A-590C-04B9-BB6B-7149474AB7E1}"/>
             </a:ext>
           </a:extLst>
@@ -7201,7 +7843,7 @@
 </p:sld>
 </file>
 
-<file path=ppt/slides/slide21.xml><?xml version="1.0" encoding="utf-8"?>
+<file path=ppt/slides/slide22.xml><?xml version="1.0" encoding="utf-8"?>
 <p:sld xmlns:a="http://schemas.openxmlformats.org/drawingml/2006/main" xmlns:r="http://schemas.openxmlformats.org/officeDocument/2006/relationships" xmlns:p="http://schemas.openxmlformats.org/presentationml/2006/main">
   <p:cSld>
     <p:spTree>
@@ -7715,6 +8357,159 @@
 </file>
 
 <file path=ppt/slides/slide5.xml><?xml version="1.0" encoding="utf-8"?>
+<p:sld xmlns:a="http://schemas.openxmlformats.org/drawingml/2006/main" xmlns:r="http://schemas.openxmlformats.org/officeDocument/2006/relationships" xmlns:p="http://schemas.openxmlformats.org/presentationml/2006/main">
+  <p:cSld>
+    <p:spTree>
+      <p:nvGrpSpPr>
+        <p:cNvPr id="1" name="">
+          <a:extLst>
+            <a:ext uri="{FF2B5EF4-FFF2-40B4-BE49-F238E27FC236}">
+              <a16:creationId xmlns:a16="http://schemas.microsoft.com/office/drawing/2014/main" id="{24312F7B-D59E-7A93-5DFD-5D3436B158C9}"/>
+            </a:ext>
+          </a:extLst>
+        </p:cNvPr>
+        <p:cNvGrpSpPr/>
+        <p:nvPr/>
+      </p:nvGrpSpPr>
+      <p:grpSpPr>
+        <a:xfrm>
+          <a:off x="0" y="0"/>
+          <a:ext cx="0" cy="0"/>
+          <a:chOff x="0" y="0"/>
+          <a:chExt cx="0" cy="0"/>
+        </a:xfrm>
+      </p:grpSpPr>
+      <p:sp>
+        <p:nvSpPr>
+          <p:cNvPr id="2" name="Titolo 1">
+            <a:extLst>
+              <a:ext uri="{FF2B5EF4-FFF2-40B4-BE49-F238E27FC236}">
+                <a16:creationId xmlns:a16="http://schemas.microsoft.com/office/drawing/2014/main" id="{C88DC320-A7C6-252F-65C7-0562B353CA17}"/>
+              </a:ext>
+            </a:extLst>
+          </p:cNvPr>
+          <p:cNvSpPr>
+            <a:spLocks noGrp="1"/>
+          </p:cNvSpPr>
+          <p:nvPr>
+            <p:ph type="title"/>
+          </p:nvPr>
+        </p:nvSpPr>
+        <p:spPr/>
+        <p:txBody>
+          <a:bodyPr/>
+          <a:lstStyle/>
+          <a:p>
+            <a:r>
+              <a:rPr lang="it-IT" dirty="0"/>
+              <a:t>Parte 1	</a:t>
+            </a:r>
+          </a:p>
+        </p:txBody>
+      </p:sp>
+      <p:sp>
+        <p:nvSpPr>
+          <p:cNvPr id="3" name="Segnaposto contenuto 2">
+            <a:extLst>
+              <a:ext uri="{FF2B5EF4-FFF2-40B4-BE49-F238E27FC236}">
+                <a16:creationId xmlns:a16="http://schemas.microsoft.com/office/drawing/2014/main" id="{8C6B2140-42C3-AD55-FBCD-9F9585DCD39C}"/>
+              </a:ext>
+            </a:extLst>
+          </p:cNvPr>
+          <p:cNvSpPr>
+            <a:spLocks noGrp="1"/>
+          </p:cNvSpPr>
+          <p:nvPr>
+            <p:ph idx="1"/>
+          </p:nvPr>
+        </p:nvSpPr>
+        <p:spPr>
+          <a:xfrm>
+            <a:off x="1451579" y="2057460"/>
+            <a:ext cx="9603275" cy="3891784"/>
+          </a:xfrm>
+        </p:spPr>
+        <p:txBody>
+          <a:bodyPr>
+            <a:normAutofit fontScale="92500" lnSpcReduction="10000"/>
+          </a:bodyPr>
+          <a:lstStyle/>
+          <a:p>
+            <a:r>
+              <a:rPr lang="it-IT" b="1" dirty="0"/>
+              <a:t>I Risonatori</a:t>
+            </a:r>
+            <a:br>
+              <a:rPr lang="it-IT" b="1" dirty="0"/>
+            </a:br>
+            <a:r>
+              <a:rPr lang="it-IT" b="1" dirty="0"/>
+              <a:t>	</a:t>
+            </a:r>
+            <a:r>
+              <a:rPr lang="it-IT" sz="2400" dirty="0"/>
+              <a:t>-</a:t>
+            </a:r>
+            <a:r>
+              <a:rPr lang="it-IT" sz="2400" b="1" dirty="0"/>
+              <a:t> </a:t>
+            </a:r>
+            <a:r>
+              <a:rPr lang="it-IT" sz="2400" dirty="0"/>
+              <a:t>secondo Hertz: circuiti semichiusi o conduttori rettilinei divisi a 	metà</a:t>
+            </a:r>
+            <a:br>
+              <a:rPr lang="it-IT" sz="2400" dirty="0"/>
+            </a:br>
+            <a:r>
+              <a:rPr lang="it-IT" sz="2400" dirty="0"/>
+              <a:t>	</a:t>
+            </a:r>
+            <a:br>
+              <a:rPr lang="it-IT" sz="2400" dirty="0"/>
+            </a:br>
+            <a:r>
+              <a:rPr lang="it-IT" sz="2400" dirty="0"/>
+              <a:t>	- secondo Righi: lastra di vetro con dell’argento depositato sopra 	(«</a:t>
+            </a:r>
+            <a:r>
+              <a:rPr lang="it-IT" sz="2400" i="1" dirty="0"/>
+              <a:t>Si sa da tempo, 	benché la ragione non ne sia forse ancora ben 	chiarita, che, a parità di differenza di 	potenziale, si ottengono scintille 	assai più lunghe allorché esse si generano alla superficie 	d’un 	corpo 	isolante o semiconduttore piuttosto che nell'aria libera.</a:t>
+            </a:r>
+            <a:r>
+              <a:rPr lang="it-IT" sz="2400" dirty="0"/>
+              <a:t>»)</a:t>
+            </a:r>
+            <a:br>
+              <a:rPr lang="it-IT" sz="2400" dirty="0"/>
+            </a:br>
+            <a:r>
+              <a:rPr lang="it-IT" dirty="0"/>
+              <a:t>	</a:t>
+            </a:r>
+          </a:p>
+          <a:p>
+            <a:endParaRPr lang="it-IT" dirty="0"/>
+          </a:p>
+          <a:p>
+            <a:endParaRPr lang="it-IT" dirty="0"/>
+          </a:p>
+        </p:txBody>
+      </p:sp>
+    </p:spTree>
+    <p:extLst>
+      <p:ext uri="{BB962C8B-B14F-4D97-AF65-F5344CB8AC3E}">
+        <p14:creationId xmlns:p14="http://schemas.microsoft.com/office/powerpoint/2010/main" val="1964464591"/>
+      </p:ext>
+    </p:extLst>
+  </p:cSld>
+  <p:clrMapOvr>
+    <a:masterClrMapping/>
+  </p:clrMapOvr>
+</p:sld>
+</file>
+
+<file path=ppt/slides/slide6.xml><?xml version="1.0" encoding="utf-8"?>
 <p:sld xmlns:a="http://schemas.openxmlformats.org/drawingml/2006/main" xmlns:r="http://schemas.openxmlformats.org/officeDocument/2006/relationships" xmlns:p="http://schemas.openxmlformats.org/presentationml/2006/main">
   <p:cSld>
     <p:spTree>
@@ -7835,7 +8630,7 @@
 </p:sld>
 </file>
 
-<file path=ppt/slides/slide6.xml><?xml version="1.0" encoding="utf-8"?>
+<file path=ppt/slides/slide7.xml><?xml version="1.0" encoding="utf-8"?>
 <p:sld xmlns:a="http://schemas.openxmlformats.org/drawingml/2006/main" xmlns:r="http://schemas.openxmlformats.org/officeDocument/2006/relationships" xmlns:p="http://schemas.openxmlformats.org/presentationml/2006/main">
   <p:cSld>
     <p:spTree>
@@ -7925,133 +8720,6 @@
 </p:sld>
 </file>
 
-<file path=ppt/slides/slide7.xml><?xml version="1.0" encoding="utf-8"?>
-<p:sld xmlns:a="http://schemas.openxmlformats.org/drawingml/2006/main" xmlns:r="http://schemas.openxmlformats.org/officeDocument/2006/relationships" xmlns:p="http://schemas.openxmlformats.org/presentationml/2006/main">
-  <p:cSld>
-    <p:spTree>
-      <p:nvGrpSpPr>
-        <p:cNvPr id="1" name=""/>
-        <p:cNvGrpSpPr/>
-        <p:nvPr/>
-      </p:nvGrpSpPr>
-      <p:grpSpPr>
-        <a:xfrm>
-          <a:off x="0" y="0"/>
-          <a:ext cx="0" cy="0"/>
-          <a:chOff x="0" y="0"/>
-          <a:chExt cx="0" cy="0"/>
-        </a:xfrm>
-      </p:grpSpPr>
-      <p:sp>
-        <p:nvSpPr>
-          <p:cNvPr id="2" name="Titolo 1">
-            <a:extLst>
-              <a:ext uri="{FF2B5EF4-FFF2-40B4-BE49-F238E27FC236}">
-                <a16:creationId xmlns:a16="http://schemas.microsoft.com/office/drawing/2014/main" id="{EA3F17B3-2D6C-9EF7-1099-26D5D194A1BB}"/>
-              </a:ext>
-            </a:extLst>
-          </p:cNvPr>
-          <p:cNvSpPr>
-            <a:spLocks noGrp="1"/>
-          </p:cNvSpPr>
-          <p:nvPr>
-            <p:ph type="title"/>
-          </p:nvPr>
-        </p:nvSpPr>
-        <p:spPr/>
-        <p:txBody>
-          <a:bodyPr/>
-          <a:lstStyle/>
-          <a:p>
-            <a:r>
-              <a:rPr lang="it-IT" dirty="0"/>
-              <a:t>Parte 1	</a:t>
-            </a:r>
-          </a:p>
-        </p:txBody>
-      </p:sp>
-      <p:sp>
-        <p:nvSpPr>
-          <p:cNvPr id="3" name="Segnaposto contenuto 2">
-            <a:extLst>
-              <a:ext uri="{FF2B5EF4-FFF2-40B4-BE49-F238E27FC236}">
-                <a16:creationId xmlns:a16="http://schemas.microsoft.com/office/drawing/2014/main" id="{7770382D-42DF-21CE-CB3D-C8CCE33A31F3}"/>
-              </a:ext>
-            </a:extLst>
-          </p:cNvPr>
-          <p:cNvSpPr>
-            <a:spLocks noGrp="1"/>
-          </p:cNvSpPr>
-          <p:nvPr>
-            <p:ph idx="1"/>
-          </p:nvPr>
-        </p:nvSpPr>
-        <p:spPr/>
-        <p:txBody>
-          <a:bodyPr/>
-          <a:lstStyle/>
-          <a:p>
-            <a:r>
-              <a:rPr lang="it-IT" sz="2400" b="1" dirty="0"/>
-              <a:t>Il risonatore come analizzatore ottico </a:t>
-            </a:r>
-            <a:r>
-              <a:rPr lang="it-IT" sz="2400" dirty="0"/>
-              <a:t>(«</a:t>
-            </a:r>
-            <a:r>
-              <a:rPr lang="it-IT" i="1" dirty="0"/>
-              <a:t>Per mezzo del cerchio graduato OP ( </a:t>
-            </a:r>
-            <a:r>
-              <a:rPr lang="it-IT" i="1" dirty="0" err="1"/>
-              <a:t>fig</a:t>
-            </a:r>
-            <a:r>
-              <a:rPr lang="it-IT" i="1" dirty="0"/>
-              <a:t> . 9 ) annesso al risonatore, questo apparecchio si adopera press ' a poco come un analizzatore ottico.</a:t>
-            </a:r>
-            <a:r>
-              <a:rPr lang="it-IT" sz="2400" dirty="0"/>
-              <a:t>» pagina 49 del .pdf)</a:t>
-            </a:r>
-          </a:p>
-          <a:p>
-            <a:r>
-              <a:rPr lang="it-IT" sz="2400" dirty="0"/>
-              <a:t>Il capitolo si chiude evidenziando la grande portata degli apparati: l'Apparecchio II permette di osservare scintille distinte fino a </a:t>
-            </a:r>
-            <a:r>
-              <a:rPr lang="it-IT" sz="2400" b="1" dirty="0"/>
-              <a:t>20 metri di distanza</a:t>
-            </a:r>
-            <a:r>
-              <a:rPr lang="it-IT" sz="2400" dirty="0"/>
-              <a:t> dal risonatore (circa 190 lunghezze d'onda), mentre l'Apparecchio III supera i </a:t>
-            </a:r>
-            <a:r>
-              <a:rPr lang="it-IT" sz="2400" b="1" dirty="0"/>
-              <a:t>25 metri.</a:t>
-            </a:r>
-          </a:p>
-          <a:p>
-            <a:endParaRPr lang="it-IT" sz="2400" b="1" dirty="0"/>
-          </a:p>
-        </p:txBody>
-      </p:sp>
-    </p:spTree>
-    <p:extLst>
-      <p:ext uri="{BB962C8B-B14F-4D97-AF65-F5344CB8AC3E}">
-        <p14:creationId xmlns:p14="http://schemas.microsoft.com/office/powerpoint/2010/main" val="3165537485"/>
-      </p:ext>
-    </p:extLst>
-  </p:cSld>
-  <p:clrMapOvr>
-    <a:masterClrMapping/>
-  </p:clrMapOvr>
-</p:sld>
-</file>
-
 <file path=ppt/slides/slide8.xml><?xml version="1.0" encoding="utf-8"?>
 <p:sld xmlns:a="http://schemas.openxmlformats.org/drawingml/2006/main" xmlns:r="http://schemas.openxmlformats.org/officeDocument/2006/relationships" xmlns:p="http://schemas.openxmlformats.org/presentationml/2006/main">
   <p:cSld>
@@ -8074,7 +8742,7 @@
           <p:cNvPr id="2" name="Titolo 1">
             <a:extLst>
               <a:ext uri="{FF2B5EF4-FFF2-40B4-BE49-F238E27FC236}">
-                <a16:creationId xmlns:a16="http://schemas.microsoft.com/office/drawing/2014/main" id="{AE7ABC86-16EC-1549-C2D1-F7AD18CB87FE}"/>
+                <a16:creationId xmlns:a16="http://schemas.microsoft.com/office/drawing/2014/main" id="{EA3F17B3-2D6C-9EF7-1099-26D5D194A1BB}"/>
               </a:ext>
             </a:extLst>
           </p:cNvPr>
@@ -8092,7 +8760,7 @@
           <a:p>
             <a:r>
               <a:rPr lang="it-IT" dirty="0"/>
-              <a:t>Parte 1</a:t>
+              <a:t>Parte 1	</a:t>
             </a:r>
           </a:p>
         </p:txBody>
@@ -8102,7 +8770,7 @@
           <p:cNvPr id="3" name="Segnaposto contenuto 2">
             <a:extLst>
               <a:ext uri="{FF2B5EF4-FFF2-40B4-BE49-F238E27FC236}">
-                <a16:creationId xmlns:a16="http://schemas.microsoft.com/office/drawing/2014/main" id="{2235BC58-E8E7-47BE-74C5-B1AAE9E47E59}"/>
+                <a16:creationId xmlns:a16="http://schemas.microsoft.com/office/drawing/2014/main" id="{7770382D-42DF-21CE-CB3D-C8CCE33A31F3}"/>
               </a:ext>
             </a:extLst>
           </p:cNvPr>
@@ -8113,92 +8781,63 @@
             <p:ph idx="1"/>
           </p:nvPr>
         </p:nvSpPr>
-        <p:spPr>
-          <a:xfrm>
-            <a:off x="1451579" y="2015732"/>
-            <a:ext cx="9603275" cy="3895211"/>
-          </a:xfrm>
-        </p:spPr>
-        <p:txBody>
-          <a:bodyPr>
-            <a:normAutofit fontScale="85000" lnSpcReduction="20000"/>
-          </a:bodyPr>
-          <a:lstStyle/>
-          <a:p>
-            <a:r>
-              <a:rPr lang="it-IT" sz="2100" dirty="0"/>
-              <a:t>Righi spiega come utilizzare il risonatore come un vero e proprio analizzatore ottico</a:t>
-            </a:r>
-            <a:r>
-              <a:rPr lang="it-IT" sz="2100" b="1" dirty="0"/>
-              <a:t>:</a:t>
-            </a:r>
-          </a:p>
-          <a:p>
-            <a:pPr marL="457200" lvl="0" indent="-457200">
-              <a:buFont typeface="+mj-lt"/>
-              <a:buAutoNum type="arabicPeriod"/>
-            </a:pPr>
-            <a:r>
-              <a:rPr lang="it-IT" sz="2100" b="1" dirty="0"/>
-              <a:t>Azimut delle oscillazioni:</a:t>
-            </a:r>
-            <a:r>
-              <a:rPr lang="it-IT" sz="2100" dirty="0"/>
-              <a:t> ruotando il risonatore attorno al proprio asse orizzontale si individua il piano di polarizzazione per il quale la frequenza e la luminosità delle scintille diventano massime.</a:t>
-            </a:r>
-          </a:p>
-          <a:p>
-            <a:pPr marL="457200" lvl="0" indent="-457200">
-              <a:buFont typeface="+mj-lt"/>
-              <a:buAutoNum type="arabicPeriod"/>
-            </a:pPr>
-            <a:r>
-              <a:rPr lang="it-IT" sz="2100" b="1" dirty="0"/>
-              <a:t>Misura dell'intensità della radiazione:</a:t>
-            </a:r>
-            <a:r>
-              <a:rPr lang="it-IT" sz="2100" dirty="0"/>
-              <a:t> inclinando il risonatore fino a che le scintille non spariscono, il rapporto inverso dei coseni degli angoli determinati prima e dopo l'interposizione di un corpo fornisce il rapporto delle ampiezze d'onda.</a:t>
-            </a:r>
-          </a:p>
-          <a:p>
-            <a:pPr marL="457200" lvl="0" indent="-457200">
-              <a:buFont typeface="+mj-lt"/>
-              <a:buAutoNum type="arabicPeriod"/>
-            </a:pPr>
-            <a:r>
-              <a:rPr lang="it-IT" sz="2100" b="1" dirty="0"/>
-              <a:t>Deviazione dei raggi:</a:t>
-            </a:r>
-            <a:r>
-              <a:rPr lang="it-IT" sz="2100" dirty="0"/>
-              <a:t> permette di seguire la direzione delle radiazioni emergenti da prismi o lenti.</a:t>
-            </a:r>
-          </a:p>
-          <a:p>
-            <a:pPr marL="457200" lvl="0" indent="-457200">
-              <a:buFont typeface="+mj-lt"/>
-              <a:buAutoNum type="arabicPeriod"/>
-            </a:pPr>
-            <a:r>
-              <a:rPr lang="it-IT" sz="2100" b="1" dirty="0"/>
-              <a:t>Analisi di vibrazioni ellittiche o circolari</a:t>
-            </a:r>
-            <a:r>
-              <a:rPr lang="it-IT" sz="2100" dirty="0"/>
-              <a:t>: ruotando il risonatore nei vari azimut e cronometrando la frequenza delle scintille mediante un metronomo, è possibile stabilire se l'onda è a polarizzazione rettilinea, ellittica o circolare.</a:t>
-            </a:r>
-          </a:p>
-          <a:p>
-            <a:endParaRPr lang="it-IT" dirty="0"/>
+        <p:spPr/>
+        <p:txBody>
+          <a:bodyPr/>
+          <a:lstStyle/>
+          <a:p>
+            <a:r>
+              <a:rPr lang="it-IT" sz="2400" b="1" dirty="0"/>
+              <a:t>Il risonatore come analizzatore ottico </a:t>
+            </a:r>
+            <a:r>
+              <a:rPr lang="it-IT" sz="2400" dirty="0"/>
+              <a:t>(«</a:t>
+            </a:r>
+            <a:r>
+              <a:rPr lang="it-IT" i="1" dirty="0"/>
+              <a:t>Per mezzo del cerchio graduato OP ( </a:t>
+            </a:r>
+            <a:r>
+              <a:rPr lang="it-IT" i="1" dirty="0" err="1"/>
+              <a:t>fig</a:t>
+            </a:r>
+            <a:r>
+              <a:rPr lang="it-IT" i="1" dirty="0"/>
+              <a:t> . 9 ) annesso al risonatore, questo apparecchio si adopera press ' a poco come un analizzatore ottico.</a:t>
+            </a:r>
+            <a:r>
+              <a:rPr lang="it-IT" sz="2400" dirty="0"/>
+              <a:t>» pagina 49 del .pdf)</a:t>
+            </a:r>
+          </a:p>
+          <a:p>
+            <a:r>
+              <a:rPr lang="it-IT" sz="2400" dirty="0"/>
+              <a:t>Il capitolo si chiude evidenziando la grande portata degli apparati: l'Apparecchio II permette di osservare scintille distinte fino a </a:t>
+            </a:r>
+            <a:r>
+              <a:rPr lang="it-IT" sz="2400" b="1" dirty="0"/>
+              <a:t>20 metri di distanza</a:t>
+            </a:r>
+            <a:r>
+              <a:rPr lang="it-IT" sz="2400" dirty="0"/>
+              <a:t> dal risonatore (circa 190 lunghezze d'onda), mentre l'Apparecchio III supera i </a:t>
+            </a:r>
+            <a:r>
+              <a:rPr lang="it-IT" sz="2400" b="1" dirty="0"/>
+              <a:t>25 metri.</a:t>
+            </a:r>
+          </a:p>
+          <a:p>
+            <a:endParaRPr lang="it-IT" sz="2400" b="1" dirty="0"/>
           </a:p>
         </p:txBody>
       </p:sp>
     </p:spTree>
     <p:extLst>
       <p:ext uri="{BB962C8B-B14F-4D97-AF65-F5344CB8AC3E}">
-        <p14:creationId xmlns:p14="http://schemas.microsoft.com/office/powerpoint/2010/main" val="435440185"/>
+        <p14:creationId xmlns:p14="http://schemas.microsoft.com/office/powerpoint/2010/main" val="3165537485"/>
       </p:ext>
     </p:extLst>
   </p:cSld>
@@ -8230,7 +8869,7 @@
           <p:cNvPr id="2" name="Titolo 1">
             <a:extLst>
               <a:ext uri="{FF2B5EF4-FFF2-40B4-BE49-F238E27FC236}">
-                <a16:creationId xmlns:a16="http://schemas.microsoft.com/office/drawing/2014/main" id="{BE3E8445-21EB-A1C9-7978-31DEC1D65DC8}"/>
+                <a16:creationId xmlns:a16="http://schemas.microsoft.com/office/drawing/2014/main" id="{AE7ABC86-16EC-1549-C2D1-F7AD18CB87FE}"/>
               </a:ext>
             </a:extLst>
           </p:cNvPr>
@@ -8248,7 +8887,7 @@
           <a:p>
             <a:r>
               <a:rPr lang="it-IT" dirty="0"/>
-              <a:t>Parte 2</a:t>
+              <a:t>Parte 1</a:t>
             </a:r>
           </a:p>
         </p:txBody>
@@ -8258,7 +8897,7 @@
           <p:cNvPr id="3" name="Segnaposto contenuto 2">
             <a:extLst>
               <a:ext uri="{FF2B5EF4-FFF2-40B4-BE49-F238E27FC236}">
-                <a16:creationId xmlns:a16="http://schemas.microsoft.com/office/drawing/2014/main" id="{5AFE3D66-0521-3272-AB4C-A7B7E9CDB369}"/>
+                <a16:creationId xmlns:a16="http://schemas.microsoft.com/office/drawing/2014/main" id="{2235BC58-E8E7-47BE-74C5-B1AAE9E47E59}"/>
               </a:ext>
             </a:extLst>
           </p:cNvPr>
@@ -8272,70 +8911,89 @@
         <p:spPr>
           <a:xfrm>
             <a:off x="1451579" y="2015732"/>
-            <a:ext cx="9603275" cy="3851668"/>
+            <a:ext cx="9603275" cy="3895211"/>
           </a:xfrm>
         </p:spPr>
         <p:txBody>
           <a:bodyPr>
-            <a:normAutofit fontScale="92500" lnSpcReduction="20000"/>
+            <a:normAutofit fontScale="85000" lnSpcReduction="20000"/>
           </a:bodyPr>
           <a:lstStyle/>
           <a:p>
             <a:r>
-              <a:rPr lang="it-IT" sz="2200" b="1" dirty="0"/>
-              <a:t>Capitolo I – Fenomeni d’interferenza. </a:t>
-            </a:r>
-            <a:br>
-              <a:rPr lang="it-IT" dirty="0"/>
-            </a:br>
-            <a:r>
-              <a:rPr lang="it-IT" dirty="0"/>
-              <a:t>Questo capitolo riproduce in laboratorio le storiche esperienze dell’ottica ondulatoria, adattandole alle onde elettromagnetiche.</a:t>
-            </a:r>
-          </a:p>
-          <a:p>
-            <a:pPr lvl="0"/>
-            <a:r>
-              <a:rPr lang="it-IT" dirty="0"/>
-              <a:t>Onde stazionarie (§ 21): inviando le onde contro uno specchio metallico piano, la sovrapposizione dell’onda incidente e di quella riflessa crea un’onda stazionaria. Facendo scorrere il risonatore si individuano i ventri (massimo scintillio) e i nodi (estinzione delle scintille), permettendo di misurare direttamente la lunghezza d’onda λ.</a:t>
-            </a:r>
-          </a:p>
-          <a:p>
-            <a:pPr lvl="0"/>
-            <a:r>
-              <a:rPr lang="it-IT" dirty="0"/>
-              <a:t>Specchi di Fresnel (§ 22-23) e </a:t>
-            </a:r>
-            <a:r>
-              <a:rPr lang="it-IT" dirty="0" err="1"/>
-              <a:t>biprisma</a:t>
-            </a:r>
-            <a:r>
-              <a:rPr lang="it-IT" dirty="0"/>
-              <a:t> (§ 26): ricreano le classiche disposizioni ottiche di Fresnel utilizzando due specchi metallici inclinati o un </a:t>
-            </a:r>
-            <a:r>
-              <a:rPr lang="it-IT" dirty="0" err="1"/>
-              <a:t>biprisma</a:t>
-            </a:r>
-            <a:r>
-              <a:rPr lang="it-IT" dirty="0"/>
-              <a:t> in paraffina o altro dielettrico, producendo frange d’interferenza osservabili con il risonatore.</a:t>
-            </a:r>
-          </a:p>
-          <a:p>
-            <a:pPr lvl="0"/>
-            <a:r>
-              <a:rPr lang="it-IT" dirty="0"/>
-              <a:t>Determinazione degli indici di rifrazione (§ 24) e interferenza ad uno specchio (§ 25).</a:t>
-            </a:r>
+              <a:rPr lang="it-IT" sz="2100" dirty="0"/>
+              <a:t>Righi spiega come utilizzare il risonatore come un vero e proprio analizzatore ottico</a:t>
+            </a:r>
+            <a:r>
+              <a:rPr lang="it-IT" sz="2100" b="1" dirty="0"/>
+              <a:t>:</a:t>
+            </a:r>
+          </a:p>
+          <a:p>
+            <a:pPr marL="457200" lvl="0" indent="-457200">
+              <a:buFont typeface="+mj-lt"/>
+              <a:buAutoNum type="arabicPeriod"/>
+            </a:pPr>
+            <a:r>
+              <a:rPr lang="it-IT" sz="2100" b="1" dirty="0"/>
+              <a:t>Azimut delle oscillazioni:</a:t>
+            </a:r>
+            <a:r>
+              <a:rPr lang="it-IT" sz="2100" dirty="0"/>
+              <a:t> ruotando il risonatore attorno al proprio asse orizzontale si individua il piano di polarizzazione per il quale la frequenza e la luminosità delle scintille diventano massime.</a:t>
+            </a:r>
+          </a:p>
+          <a:p>
+            <a:pPr marL="457200" lvl="0" indent="-457200">
+              <a:buFont typeface="+mj-lt"/>
+              <a:buAutoNum type="arabicPeriod"/>
+            </a:pPr>
+            <a:r>
+              <a:rPr lang="it-IT" sz="2100" b="1" dirty="0"/>
+              <a:t>Misura dell'intensità della radiazione:</a:t>
+            </a:r>
+            <a:r>
+              <a:rPr lang="it-IT" sz="2100" dirty="0"/>
+              <a:t> inclinando il risonatore fino a che le scintille non spariscono, il rapporto inverso dei coseni degli angoli determinati prima e dopo l'interposizione di un corpo fornisce il rapporto delle ampiezze d'onda.</a:t>
+            </a:r>
+          </a:p>
+          <a:p>
+            <a:pPr marL="457200" lvl="0" indent="-457200">
+              <a:buFont typeface="+mj-lt"/>
+              <a:buAutoNum type="arabicPeriod"/>
+            </a:pPr>
+            <a:r>
+              <a:rPr lang="it-IT" sz="2100" b="1" dirty="0"/>
+              <a:t>Deviazione dei raggi:</a:t>
+            </a:r>
+            <a:r>
+              <a:rPr lang="it-IT" sz="2100" dirty="0"/>
+              <a:t> permette di seguire la direzione delle radiazioni emergenti da prismi o lenti.</a:t>
+            </a:r>
+          </a:p>
+          <a:p>
+            <a:pPr marL="457200" lvl="0" indent="-457200">
+              <a:buFont typeface="+mj-lt"/>
+              <a:buAutoNum type="arabicPeriod"/>
+            </a:pPr>
+            <a:r>
+              <a:rPr lang="it-IT" sz="2100" b="1" dirty="0"/>
+              <a:t>Analisi di vibrazioni ellittiche o circolari</a:t>
+            </a:r>
+            <a:r>
+              <a:rPr lang="it-IT" sz="2100" dirty="0"/>
+              <a:t>: ruotando il risonatore nei vari azimut e cronometrando la frequenza delle scintille mediante un metronomo, è possibile stabilire se l'onda è a polarizzazione rettilinea, ellittica o circolare.</a:t>
+            </a:r>
+          </a:p>
+          <a:p>
+            <a:endParaRPr lang="it-IT" dirty="0"/>
           </a:p>
         </p:txBody>
       </p:sp>
     </p:spTree>
     <p:extLst>
       <p:ext uri="{BB962C8B-B14F-4D97-AF65-F5344CB8AC3E}">
-        <p14:creationId xmlns:p14="http://schemas.microsoft.com/office/powerpoint/2010/main" val="2791653420"/>
+        <p14:creationId xmlns:p14="http://schemas.microsoft.com/office/powerpoint/2010/main" val="435440185"/>
       </p:ext>
     </p:extLst>
   </p:cSld>

</xml_diff>

<commit_message>
Raffinato la presentazione. Cambiato da <ditta Nicola Zanichelli> a <Zanichelli> nella bibliografia
</commit_message>
<xml_diff>
--- a/presentazione_sunto_libro_di_Righi/presentazione_veloce_testo_Righi.pptx
+++ b/presentazione_sunto_libro_di_Righi/presentazione_veloce_testo_Righi.pptx
@@ -15,8 +15,8 @@
     <p:sldId id="281" r:id="rId6"/>
     <p:sldId id="258" r:id="rId7"/>
     <p:sldId id="259" r:id="rId8"/>
-    <p:sldId id="268" r:id="rId9"/>
-    <p:sldId id="260" r:id="rId10"/>
+    <p:sldId id="260" r:id="rId9"/>
+    <p:sldId id="268" r:id="rId10"/>
     <p:sldId id="261" r:id="rId11"/>
     <p:sldId id="270" r:id="rId12"/>
     <p:sldId id="271" r:id="rId13"/>
@@ -218,7 +218,7 @@
           <a:p>
             <a:fld id="{5F163503-BC98-4576-AAA0-4ED2B62CB37F}" type="datetimeFigureOut">
               <a:rPr lang="it-IT" smtClean="0"/>
-              <a:t>11/10/2026</a:t>
+              <a:t>12/10/2026</a:t>
             </a:fld>
             <a:endParaRPr lang="it-IT"/>
           </a:p>
@@ -2716,7 +2716,7 @@
           <a:p>
             <a:fld id="{48A87A34-81AB-432B-8DAE-1953F412C126}" type="datetimeFigureOut">
               <a:rPr lang="en-US" dirty="0"/>
-              <a:t>10/11/2026</a:t>
+              <a:t>10/12/2026</a:t>
             </a:fld>
             <a:endParaRPr lang="en-US" dirty="0"/>
           </a:p>
@@ -2922,7 +2922,7 @@
           <a:p>
             <a:fld id="{48A87A34-81AB-432B-8DAE-1953F412C126}" type="datetimeFigureOut">
               <a:rPr lang="en-US" dirty="0"/>
-              <a:t>10/11/2026</a:t>
+              <a:t>10/12/2026</a:t>
             </a:fld>
             <a:endParaRPr lang="en-US" dirty="0"/>
           </a:p>
@@ -3132,7 +3132,7 @@
           <a:p>
             <a:fld id="{48A87A34-81AB-432B-8DAE-1953F412C126}" type="datetimeFigureOut">
               <a:rPr lang="en-US" dirty="0"/>
-              <a:t>10/11/2026</a:t>
+              <a:t>10/12/2026</a:t>
             </a:fld>
             <a:endParaRPr lang="en-US" dirty="0"/>
           </a:p>
@@ -3328,7 +3328,7 @@
           <a:p>
             <a:fld id="{48A87A34-81AB-432B-8DAE-1953F412C126}" type="datetimeFigureOut">
               <a:rPr lang="en-US" dirty="0"/>
-              <a:t>10/11/2026</a:t>
+              <a:t>10/12/2026</a:t>
             </a:fld>
             <a:endParaRPr lang="en-US" dirty="0"/>
           </a:p>
@@ -3602,7 +3602,7 @@
           <a:p>
             <a:fld id="{48A87A34-81AB-432B-8DAE-1953F412C126}" type="datetimeFigureOut">
               <a:rPr lang="en-US" dirty="0"/>
-              <a:t>10/11/2026</a:t>
+              <a:t>10/12/2026</a:t>
             </a:fld>
             <a:endParaRPr lang="en-US" dirty="0"/>
           </a:p>
@@ -3865,7 +3865,7 @@
           <a:p>
             <a:fld id="{48A87A34-81AB-432B-8DAE-1953F412C126}" type="datetimeFigureOut">
               <a:rPr lang="en-US" dirty="0"/>
-              <a:t>10/11/2026</a:t>
+              <a:t>10/12/2026</a:t>
             </a:fld>
             <a:endParaRPr lang="en-US" dirty="0"/>
           </a:p>
@@ -4276,7 +4276,7 @@
           <a:p>
             <a:fld id="{48A87A34-81AB-432B-8DAE-1953F412C126}" type="datetimeFigureOut">
               <a:rPr lang="en-US" dirty="0"/>
-              <a:t>10/11/2026</a:t>
+              <a:t>10/12/2026</a:t>
             </a:fld>
             <a:endParaRPr lang="en-US" dirty="0"/>
           </a:p>
@@ -4420,7 +4420,7 @@
           <a:p>
             <a:fld id="{48A87A34-81AB-432B-8DAE-1953F412C126}" type="datetimeFigureOut">
               <a:rPr lang="en-US" dirty="0"/>
-              <a:t>10/11/2026</a:t>
+              <a:t>10/12/2026</a:t>
             </a:fld>
             <a:endParaRPr lang="en-US" dirty="0"/>
           </a:p>
@@ -4541,7 +4541,7 @@
           <a:p>
             <a:fld id="{48A87A34-81AB-432B-8DAE-1953F412C126}" type="datetimeFigureOut">
               <a:rPr lang="en-US" dirty="0"/>
-              <a:t>10/11/2026</a:t>
+              <a:t>10/12/2026</a:t>
             </a:fld>
             <a:endParaRPr lang="en-US" dirty="0"/>
           </a:p>
@@ -4787,7 +4787,7 @@
           <a:p>
             <a:fld id="{48A87A34-81AB-432B-8DAE-1953F412C126}" type="datetimeFigureOut">
               <a:rPr lang="en-US" dirty="0"/>
-              <a:t>10/11/2026</a:t>
+              <a:t>10/12/2026</a:t>
             </a:fld>
             <a:endParaRPr lang="en-US" dirty="0"/>
           </a:p>
@@ -5224,7 +5224,7 @@
             <a:fld id="{48A87A34-81AB-432B-8DAE-1953F412C126}" type="datetimeFigureOut">
               <a:rPr lang="en-US" dirty="0"/>
               <a:pPr/>
-              <a:t>10/11/2026</a:t>
+              <a:t>10/12/2026</a:t>
             </a:fld>
             <a:endParaRPr lang="en-US" dirty="0"/>
           </a:p>
@@ -5547,7 +5547,7 @@
             <a:fld id="{48A87A34-81AB-432B-8DAE-1953F412C126}" type="datetimeFigureOut">
               <a:rPr lang="en-US" dirty="0"/>
               <a:pPr/>
-              <a:t>10/11/2026</a:t>
+              <a:t>10/12/2026</a:t>
             </a:fld>
             <a:endParaRPr lang="en-US" dirty="0"/>
           </a:p>
@@ -6413,7 +6413,7 @@
             </a:r>
             <a:r>
               <a:rPr lang="it-IT" dirty="0"/>
-              <a:t>: Viene esaminata la diffrazione attraverso diaframmi di Fresnel (§ 31), fenditure rettilinee (§ 32) e sfiorando l'orlo di corpi opachi (§ 33).</a:t>
+              <a:t>: Viene esaminata la diffrazione attraverso diaframma di Fresnel (§ 31), fenditure rettilinee (§ 32) e sfiorando l'orlo di corpi opachi (§ 33).</a:t>
             </a:r>
           </a:p>
           <a:p>
@@ -6634,7 +6634,12 @@
             <p:ph idx="1"/>
           </p:nvPr>
         </p:nvSpPr>
-        <p:spPr/>
+        <p:spPr>
+          <a:xfrm>
+            <a:off x="1451579" y="2015731"/>
+            <a:ext cx="9603275" cy="3877069"/>
+          </a:xfrm>
+        </p:spPr>
         <p:txBody>
           <a:bodyPr/>
           <a:lstStyle/>
@@ -6651,29 +6656,26 @@
             </a:r>
           </a:p>
           <a:p>
-            <a:pPr lvl="0"/>
-            <a:r>
-              <a:rPr lang="it-IT" b="1" dirty="0"/>
+            <a:pPr lvl="1"/>
+            <a:r>
+              <a:rPr lang="it-IT" sz="2000" b="1" dirty="0"/>
               <a:t>Leggi della riflessione (§ 38-42)</a:t>
             </a:r>
             <a:r>
-              <a:rPr lang="it-IT" dirty="0"/>
+              <a:rPr lang="it-IT" sz="2000" dirty="0"/>
               <a:t>: Verifica sperimentale degli angoli di riflessione e delle variazioni d'intensità in base all'angolo d'incidenza e al piano di polarizzazione.</a:t>
             </a:r>
           </a:p>
           <a:p>
-            <a:pPr lvl="0"/>
-            <a:r>
-              <a:rPr lang="it-IT" b="1" dirty="0"/>
+            <a:pPr lvl="1"/>
+            <a:r>
+              <a:rPr lang="it-IT" sz="2000" b="1" dirty="0"/>
               <a:t>Polarizzazione circolare ed ellittica per riflessione metallica (§ 43)</a:t>
             </a:r>
             <a:r>
-              <a:rPr lang="it-IT" dirty="0"/>
+              <a:rPr lang="it-IT" sz="2000" dirty="0"/>
               <a:t>: Righi descrive la prima realizzazione sperimentale in assoluto di onde elettromagnetiche a polarizzazione circolare ed ellittica ottenute mediante riflessione su lastre metalliche</a:t>
             </a:r>
-          </a:p>
-          <a:p>
-            <a:endParaRPr lang="it-IT" dirty="0"/>
           </a:p>
         </p:txBody>
       </p:sp>
@@ -6772,15 +6774,7 @@
           <a:p>
             <a:r>
               <a:rPr lang="it-IT" dirty="0"/>
-              <a:t>Analizza i fenomeni di deviazione e polarizzazione per trasmissione</a:t>
-            </a:r>
-            <a:r>
-              <a:rPr lang="it-IT" baseline="30000" dirty="0"/>
-              <a:t>[1]</a:t>
-            </a:r>
-            <a:r>
-              <a:rPr lang="it-IT" dirty="0"/>
-              <a:t>:</a:t>
+              <a:t>Analizza i fenomeni di deviazione e polarizzazione per trasmissione:</a:t>
             </a:r>
           </a:p>
           <a:p>
@@ -6948,7 +6942,15 @@
             </a:r>
             <a:r>
               <a:rPr lang="it-IT" dirty="0"/>
-              <a:t>: Righi scoprì per primo che il legno d'abete (a causa della sua struttura a fibre orientate) si comporta come un mezzo birifrangente per le onde elettromagnetiche.</a:t>
+              <a:t>: Righi scoprì («</a:t>
+            </a:r>
+            <a:r>
+              <a:rPr lang="it-IT" i="1" dirty="0"/>
+              <a:t>il fenomeno […] fu ottenuto per la prima volta da me all’inizio del 1894.</a:t>
+            </a:r>
+            <a:r>
+              <a:rPr lang="it-IT" dirty="0"/>
+              <a:t>») che il legno d'abete (a causa della sua struttura a fibre orientate) si comporta come un mezzo birifrangente per le onde elettromagnetiche.</a:t>
             </a:r>
           </a:p>
           <a:p>
@@ -7097,15 +7099,7 @@
             </a:r>
             <a:r>
               <a:rPr lang="it-IT" dirty="0"/>
-              <a:t>: Riprende la teoria matematica di Hertz sull'oscillatore elementare (doppietto elettrico) e la estende al caso di due oscillazioni elettriche ortogonali</a:t>
-            </a:r>
-            <a:r>
-              <a:rPr lang="it-IT" baseline="30000" dirty="0"/>
-              <a:t>[1]</a:t>
-            </a:r>
-            <a:r>
-              <a:rPr lang="it-IT" dirty="0"/>
-              <a:t>.</a:t>
+              <a:t>: Riprende la teoria matematica di Hertz sull'oscillatore elementare (doppietto elettrico) e la estende al caso di due oscillazioni elettriche ortogonali.</a:t>
             </a:r>
           </a:p>
           <a:p>
@@ -7225,7 +7219,7 @@
             </a:r>
             <a:r>
               <a:rPr lang="it-IT" dirty="0"/>
-              <a:t> (pag. 217)</a:t>
+              <a:t> </a:t>
             </a:r>
           </a:p>
           <a:p>
@@ -7236,7 +7230,7 @@
             </a:r>
             <a:r>
               <a:rPr lang="it-IT" dirty="0"/>
-              <a:t>: Sviluppa il calcolo analitico delle forze elettriche e della distribuzione di campo quando un corpo isolante sferico viene immerso in un campo elettrico uniforme.</a:t>
+              <a:t>: Sviluppa il calcolo analitico delle forze elettriche, quando un corpo isolante sferico viene immerso in un campo elettrico uniforme.</a:t>
             </a:r>
           </a:p>
           <a:p>
@@ -7247,7 +7241,7 @@
             </a:r>
             <a:r>
               <a:rPr lang="it-IT" dirty="0"/>
-              <a:t>: Fornisce la giustificazione teorica per gli esperimenti sulle onde secondarie emesse dalle sfere dielettriche colpite dalla radiazione</a:t>
+              <a:t>: Fornisce la spiegazione teorica per gli esperimenti sulle onde secondarie emesse dalle sfere dielettriche colpite dalla radiazione</a:t>
             </a:r>
           </a:p>
         </p:txBody>
@@ -7361,7 +7355,7 @@
             </a:r>
             <a:r>
               <a:rPr lang="it-IT" dirty="0"/>
-              <a:t>: Estende la trattazione analitica della Nota B al caso geometrico di un cilindro dielettrico immerso in un campo elettrico uniforme.</a:t>
+              <a:t>: Estende la trattazione analitica della Nota B al caso di un cilindro dielettrico immerso in un campo elettrico uniforme.</a:t>
             </a:r>
           </a:p>
           <a:p>
@@ -7372,7 +7366,7 @@
             </a:r>
             <a:r>
               <a:rPr lang="it-IT" dirty="0"/>
-              <a:t>: Spiega matematicamente come la forma cilindrica dell'isolante alteri le linee di forza elettrica generando radiazione secondaria.</a:t>
+              <a:t>: Spiega (matematicamente) come la forma cilindrica dell'isolante alteri le linee di forza elettrica generando radiazione secondaria.</a:t>
             </a:r>
           </a:p>
         </p:txBody>
@@ -7690,7 +7684,7 @@
             </a:r>
             <a:r>
               <a:rPr lang="it-IT" dirty="0"/>
-              <a:t>: Ricava direttamente dalle equazioni differenziali fondamentali di Hertz e Maxwell le leggi e le formule analitiche della riflessione e della rifrazione.</a:t>
+              <a:t>: Ricava direttamente dalle equazioni differenziali fondamentali di Hertz le leggi e le formule analitiche della riflessione e della rifrazione.</a:t>
             </a:r>
           </a:p>
           <a:p>
@@ -7701,7 +7695,7 @@
             </a:r>
             <a:r>
               <a:rPr lang="it-IT" dirty="0"/>
-              <a:t>: Dimostra che le equazioni dell'elettromagnetismo conducono esattamente alle medesime formule dell'ottica classica (equazioni di Fresnel).</a:t>
+              <a:t>: Dimostra che le equazioni dell'elettromagnetismo conducono esattamente alle medesime formule dell'ottica classica (equazioni di Fresnel, le mette proprio in colonna, pag. 246 del .pdf).</a:t>
             </a:r>
           </a:p>
         </p:txBody>
@@ -8742,7 +8736,7 @@
           <p:cNvPr id="2" name="Titolo 1">
             <a:extLst>
               <a:ext uri="{FF2B5EF4-FFF2-40B4-BE49-F238E27FC236}">
-                <a16:creationId xmlns:a16="http://schemas.microsoft.com/office/drawing/2014/main" id="{EA3F17B3-2D6C-9EF7-1099-26D5D194A1BB}"/>
+                <a16:creationId xmlns:a16="http://schemas.microsoft.com/office/drawing/2014/main" id="{AE7ABC86-16EC-1549-C2D1-F7AD18CB87FE}"/>
               </a:ext>
             </a:extLst>
           </p:cNvPr>
@@ -8760,7 +8754,7 @@
           <a:p>
             <a:r>
               <a:rPr lang="it-IT" dirty="0"/>
-              <a:t>Parte 1	</a:t>
+              <a:t>Parte 1</a:t>
             </a:r>
           </a:p>
         </p:txBody>
@@ -8770,7 +8764,7 @@
           <p:cNvPr id="3" name="Segnaposto contenuto 2">
             <a:extLst>
               <a:ext uri="{FF2B5EF4-FFF2-40B4-BE49-F238E27FC236}">
-                <a16:creationId xmlns:a16="http://schemas.microsoft.com/office/drawing/2014/main" id="{7770382D-42DF-21CE-CB3D-C8CCE33A31F3}"/>
+                <a16:creationId xmlns:a16="http://schemas.microsoft.com/office/drawing/2014/main" id="{2235BC58-E8E7-47BE-74C5-B1AAE9E47E59}"/>
               </a:ext>
             </a:extLst>
           </p:cNvPr>
@@ -8781,63 +8775,92 @@
             <p:ph idx="1"/>
           </p:nvPr>
         </p:nvSpPr>
-        <p:spPr/>
-        <p:txBody>
-          <a:bodyPr/>
-          <a:lstStyle/>
-          <a:p>
-            <a:r>
-              <a:rPr lang="it-IT" sz="2400" b="1" dirty="0"/>
-              <a:t>Il risonatore come analizzatore ottico </a:t>
-            </a:r>
-            <a:r>
-              <a:rPr lang="it-IT" sz="2400" dirty="0"/>
-              <a:t>(«</a:t>
-            </a:r>
-            <a:r>
-              <a:rPr lang="it-IT" i="1" dirty="0"/>
-              <a:t>Per mezzo del cerchio graduato OP ( </a:t>
-            </a:r>
-            <a:r>
-              <a:rPr lang="it-IT" i="1" dirty="0" err="1"/>
-              <a:t>fig</a:t>
-            </a:r>
-            <a:r>
-              <a:rPr lang="it-IT" i="1" dirty="0"/>
-              <a:t> . 9 ) annesso al risonatore, questo apparecchio si adopera press ' a poco come un analizzatore ottico.</a:t>
-            </a:r>
-            <a:r>
-              <a:rPr lang="it-IT" sz="2400" dirty="0"/>
-              <a:t>» pagina 49 del .pdf)</a:t>
-            </a:r>
-          </a:p>
-          <a:p>
-            <a:r>
-              <a:rPr lang="it-IT" sz="2400" dirty="0"/>
-              <a:t>Il capitolo si chiude evidenziando la grande portata degli apparati: l'Apparecchio II permette di osservare scintille distinte fino a </a:t>
-            </a:r>
-            <a:r>
-              <a:rPr lang="it-IT" sz="2400" b="1" dirty="0"/>
-              <a:t>20 metri di distanza</a:t>
-            </a:r>
-            <a:r>
-              <a:rPr lang="it-IT" sz="2400" dirty="0"/>
-              <a:t> dal risonatore (circa 190 lunghezze d'onda), mentre l'Apparecchio III supera i </a:t>
-            </a:r>
-            <a:r>
-              <a:rPr lang="it-IT" sz="2400" b="1" dirty="0"/>
-              <a:t>25 metri.</a:t>
-            </a:r>
-          </a:p>
-          <a:p>
-            <a:endParaRPr lang="it-IT" sz="2400" b="1" dirty="0"/>
+        <p:spPr>
+          <a:xfrm>
+            <a:off x="1451579" y="2015732"/>
+            <a:ext cx="9603275" cy="3895211"/>
+          </a:xfrm>
+        </p:spPr>
+        <p:txBody>
+          <a:bodyPr>
+            <a:normAutofit fontScale="85000" lnSpcReduction="20000"/>
+          </a:bodyPr>
+          <a:lstStyle/>
+          <a:p>
+            <a:r>
+              <a:rPr lang="it-IT" sz="2100" dirty="0"/>
+              <a:t>Righi spiega come utilizzare il risonatore come un vero e proprio analizzatore ottico</a:t>
+            </a:r>
+            <a:r>
+              <a:rPr lang="it-IT" sz="2100" b="1" dirty="0"/>
+              <a:t>:</a:t>
+            </a:r>
+          </a:p>
+          <a:p>
+            <a:pPr marL="457200" lvl="0" indent="-457200">
+              <a:buFont typeface="+mj-lt"/>
+              <a:buAutoNum type="arabicPeriod"/>
+            </a:pPr>
+            <a:r>
+              <a:rPr lang="it-IT" sz="2100" b="1" dirty="0"/>
+              <a:t>Azimut delle oscillazioni:</a:t>
+            </a:r>
+            <a:r>
+              <a:rPr lang="it-IT" sz="2100" dirty="0"/>
+              <a:t> ruotando il risonatore attorno al proprio asse orizzontale si individua il piano di polarizzazione per il quale la frequenza e la luminosità delle scintille diventano massime.</a:t>
+            </a:r>
+          </a:p>
+          <a:p>
+            <a:pPr marL="457200" lvl="0" indent="-457200">
+              <a:buFont typeface="+mj-lt"/>
+              <a:buAutoNum type="arabicPeriod"/>
+            </a:pPr>
+            <a:r>
+              <a:rPr lang="it-IT" sz="2100" b="1" dirty="0"/>
+              <a:t>Misura dell'intensità della radiazione:</a:t>
+            </a:r>
+            <a:r>
+              <a:rPr lang="it-IT" sz="2100" dirty="0"/>
+              <a:t> inclinando il risonatore fino a che le scintille non spariscono, il rapporto inverso dei coseni degli angoli determinati prima e dopo l'interposizione di un corpo fornisce il rapporto delle ampiezze d'onda.</a:t>
+            </a:r>
+          </a:p>
+          <a:p>
+            <a:pPr marL="457200" lvl="0" indent="-457200">
+              <a:buFont typeface="+mj-lt"/>
+              <a:buAutoNum type="arabicPeriod"/>
+            </a:pPr>
+            <a:r>
+              <a:rPr lang="it-IT" sz="2100" b="1" dirty="0"/>
+              <a:t>Deviazione dei raggi:</a:t>
+            </a:r>
+            <a:r>
+              <a:rPr lang="it-IT" sz="2100" dirty="0"/>
+              <a:t> permette di seguire la direzione delle radiazioni emergenti da prismi o lenti.</a:t>
+            </a:r>
+          </a:p>
+          <a:p>
+            <a:pPr marL="457200" lvl="0" indent="-457200">
+              <a:buFont typeface="+mj-lt"/>
+              <a:buAutoNum type="arabicPeriod"/>
+            </a:pPr>
+            <a:r>
+              <a:rPr lang="it-IT" sz="2100" b="1" dirty="0"/>
+              <a:t>Analisi di vibrazioni ellittiche o circolari</a:t>
+            </a:r>
+            <a:r>
+              <a:rPr lang="it-IT" sz="2100" dirty="0"/>
+              <a:t>: ruotando il risonatore nei vari azimut e cronometrando la frequenza delle scintille mediante un metronomo, è possibile stabilire se l'onda è a polarizzazione rettilinea, ellittica o circolare.</a:t>
+            </a:r>
+          </a:p>
+          <a:p>
+            <a:endParaRPr lang="it-IT" dirty="0"/>
           </a:p>
         </p:txBody>
       </p:sp>
     </p:spTree>
     <p:extLst>
       <p:ext uri="{BB962C8B-B14F-4D97-AF65-F5344CB8AC3E}">
-        <p14:creationId xmlns:p14="http://schemas.microsoft.com/office/powerpoint/2010/main" val="3165537485"/>
+        <p14:creationId xmlns:p14="http://schemas.microsoft.com/office/powerpoint/2010/main" val="435440185"/>
       </p:ext>
     </p:extLst>
   </p:cSld>
@@ -8869,7 +8892,7 @@
           <p:cNvPr id="2" name="Titolo 1">
             <a:extLst>
               <a:ext uri="{FF2B5EF4-FFF2-40B4-BE49-F238E27FC236}">
-                <a16:creationId xmlns:a16="http://schemas.microsoft.com/office/drawing/2014/main" id="{AE7ABC86-16EC-1549-C2D1-F7AD18CB87FE}"/>
+                <a16:creationId xmlns:a16="http://schemas.microsoft.com/office/drawing/2014/main" id="{EA3F17B3-2D6C-9EF7-1099-26D5D194A1BB}"/>
               </a:ext>
             </a:extLst>
           </p:cNvPr>
@@ -8887,7 +8910,7 @@
           <a:p>
             <a:r>
               <a:rPr lang="it-IT" dirty="0"/>
-              <a:t>Parte 1</a:t>
+              <a:t>Parte 1	</a:t>
             </a:r>
           </a:p>
         </p:txBody>
@@ -8897,7 +8920,7 @@
           <p:cNvPr id="3" name="Segnaposto contenuto 2">
             <a:extLst>
               <a:ext uri="{FF2B5EF4-FFF2-40B4-BE49-F238E27FC236}">
-                <a16:creationId xmlns:a16="http://schemas.microsoft.com/office/drawing/2014/main" id="{2235BC58-E8E7-47BE-74C5-B1AAE9E47E59}"/>
+                <a16:creationId xmlns:a16="http://schemas.microsoft.com/office/drawing/2014/main" id="{7770382D-42DF-21CE-CB3D-C8CCE33A31F3}"/>
               </a:ext>
             </a:extLst>
           </p:cNvPr>
@@ -8908,92 +8931,63 @@
             <p:ph idx="1"/>
           </p:nvPr>
         </p:nvSpPr>
-        <p:spPr>
-          <a:xfrm>
-            <a:off x="1451579" y="2015732"/>
-            <a:ext cx="9603275" cy="3895211"/>
-          </a:xfrm>
-        </p:spPr>
-        <p:txBody>
-          <a:bodyPr>
-            <a:normAutofit fontScale="85000" lnSpcReduction="20000"/>
-          </a:bodyPr>
-          <a:lstStyle/>
-          <a:p>
-            <a:r>
-              <a:rPr lang="it-IT" sz="2100" dirty="0"/>
-              <a:t>Righi spiega come utilizzare il risonatore come un vero e proprio analizzatore ottico</a:t>
-            </a:r>
-            <a:r>
-              <a:rPr lang="it-IT" sz="2100" b="1" dirty="0"/>
-              <a:t>:</a:t>
-            </a:r>
-          </a:p>
-          <a:p>
-            <a:pPr marL="457200" lvl="0" indent="-457200">
-              <a:buFont typeface="+mj-lt"/>
-              <a:buAutoNum type="arabicPeriod"/>
-            </a:pPr>
-            <a:r>
-              <a:rPr lang="it-IT" sz="2100" b="1" dirty="0"/>
-              <a:t>Azimut delle oscillazioni:</a:t>
-            </a:r>
-            <a:r>
-              <a:rPr lang="it-IT" sz="2100" dirty="0"/>
-              <a:t> ruotando il risonatore attorno al proprio asse orizzontale si individua il piano di polarizzazione per il quale la frequenza e la luminosità delle scintille diventano massime.</a:t>
-            </a:r>
-          </a:p>
-          <a:p>
-            <a:pPr marL="457200" lvl="0" indent="-457200">
-              <a:buFont typeface="+mj-lt"/>
-              <a:buAutoNum type="arabicPeriod"/>
-            </a:pPr>
-            <a:r>
-              <a:rPr lang="it-IT" sz="2100" b="1" dirty="0"/>
-              <a:t>Misura dell'intensità della radiazione:</a:t>
-            </a:r>
-            <a:r>
-              <a:rPr lang="it-IT" sz="2100" dirty="0"/>
-              <a:t> inclinando il risonatore fino a che le scintille non spariscono, il rapporto inverso dei coseni degli angoli determinati prima e dopo l'interposizione di un corpo fornisce il rapporto delle ampiezze d'onda.</a:t>
-            </a:r>
-          </a:p>
-          <a:p>
-            <a:pPr marL="457200" lvl="0" indent="-457200">
-              <a:buFont typeface="+mj-lt"/>
-              <a:buAutoNum type="arabicPeriod"/>
-            </a:pPr>
-            <a:r>
-              <a:rPr lang="it-IT" sz="2100" b="1" dirty="0"/>
-              <a:t>Deviazione dei raggi:</a:t>
-            </a:r>
-            <a:r>
-              <a:rPr lang="it-IT" sz="2100" dirty="0"/>
-              <a:t> permette di seguire la direzione delle radiazioni emergenti da prismi o lenti.</a:t>
-            </a:r>
-          </a:p>
-          <a:p>
-            <a:pPr marL="457200" lvl="0" indent="-457200">
-              <a:buFont typeface="+mj-lt"/>
-              <a:buAutoNum type="arabicPeriod"/>
-            </a:pPr>
-            <a:r>
-              <a:rPr lang="it-IT" sz="2100" b="1" dirty="0"/>
-              <a:t>Analisi di vibrazioni ellittiche o circolari</a:t>
-            </a:r>
-            <a:r>
-              <a:rPr lang="it-IT" sz="2100" dirty="0"/>
-              <a:t>: ruotando il risonatore nei vari azimut e cronometrando la frequenza delle scintille mediante un metronomo, è possibile stabilire se l'onda è a polarizzazione rettilinea, ellittica o circolare.</a:t>
-            </a:r>
-          </a:p>
-          <a:p>
-            <a:endParaRPr lang="it-IT" dirty="0"/>
+        <p:spPr/>
+        <p:txBody>
+          <a:bodyPr/>
+          <a:lstStyle/>
+          <a:p>
+            <a:r>
+              <a:rPr lang="it-IT" sz="2400" b="1" dirty="0"/>
+              <a:t>Il risonatore come analizzatore ottico </a:t>
+            </a:r>
+            <a:r>
+              <a:rPr lang="it-IT" sz="2400" dirty="0"/>
+              <a:t>(«</a:t>
+            </a:r>
+            <a:r>
+              <a:rPr lang="it-IT" i="1" dirty="0"/>
+              <a:t>Per mezzo del cerchio graduato OP ( </a:t>
+            </a:r>
+            <a:r>
+              <a:rPr lang="it-IT" i="1" dirty="0" err="1"/>
+              <a:t>fig</a:t>
+            </a:r>
+            <a:r>
+              <a:rPr lang="it-IT" i="1" dirty="0"/>
+              <a:t> . 9 ) annesso al risonatore, questo apparecchio si adopera press ' a poco come un analizzatore ottico.</a:t>
+            </a:r>
+            <a:r>
+              <a:rPr lang="it-IT" sz="2400" dirty="0"/>
+              <a:t>» pagina 49 del .pdf)</a:t>
+            </a:r>
+          </a:p>
+          <a:p>
+            <a:r>
+              <a:rPr lang="it-IT" sz="2400" dirty="0"/>
+              <a:t>Il capitolo si chiude evidenziando la grande portata degli apparati: l'Apparecchio II permette di osservare scintille distinte fino a </a:t>
+            </a:r>
+            <a:r>
+              <a:rPr lang="it-IT" sz="2400" b="1" dirty="0"/>
+              <a:t>20 metri di distanza</a:t>
+            </a:r>
+            <a:r>
+              <a:rPr lang="it-IT" sz="2400" dirty="0"/>
+              <a:t> dal risonatore (circa 190 lunghezze d'onda), mentre l'Apparecchio III supera i </a:t>
+            </a:r>
+            <a:r>
+              <a:rPr lang="it-IT" sz="2400" b="1" dirty="0"/>
+              <a:t>25 metri.</a:t>
+            </a:r>
+          </a:p>
+          <a:p>
+            <a:endParaRPr lang="it-IT" sz="2400" b="1" dirty="0"/>
           </a:p>
         </p:txBody>
       </p:sp>
     </p:spTree>
     <p:extLst>
       <p:ext uri="{BB962C8B-B14F-4D97-AF65-F5344CB8AC3E}">
-        <p14:creationId xmlns:p14="http://schemas.microsoft.com/office/powerpoint/2010/main" val="435440185"/>
+        <p14:creationId xmlns:p14="http://schemas.microsoft.com/office/powerpoint/2010/main" val="3165537485"/>
       </p:ext>
     </p:extLst>
   </p:cSld>

</xml_diff>